<commit_message>
Correct the MRR register status: live, with a genuinely nil week
The movement register was labelled "refresh pending" in error. It is not
stale: Net New Customers and Expansion carry entries dated 28 Sep, 30 Sep,
1 Oct and 12 Oct, so it covers the reporting week in full.

Recomputed from it: Q3 new MRR is $12,128.64 across 79 rows (Bjorn $4,427,
Brett $3,328, Bradford $2,507, Jasmine $1,622, Ho $205, Owen $40) — the same
figure as last week because there are no new-MRR rows dated 21-27 Sep. The
last entry is 18 Sep; the next are 28 and 30 Sep, inside Q3 but after this
week.

The KPI now reads "nil this wk" for a measured zero, distinct from
"refresh pending" for a feed that has not been supplied, and the summary
states the nil week rather than implying missing data. The retention slide's
register label is corrected to live for the same reason.

Co-Authored-By: Claude Opus 5 <noreply@anthropic.com>
Claude-Session: https://claude.ai/code/session_019YTPNjRj34XzLPLC9gKxc4
</commit_message>
<xml_diff>
--- a/exec-deck/output/H&L Weekly Update - WC 21 Sep 2026.pptx
+++ b/exec-deck/output/H&L Weekly Update - WC 21 Sep 2026.pptx
@@ -26235,7 +26235,7 @@
                 <a:ea typeface="Poppins" pitchFamily="34" charset="-122"/>
                 <a:cs typeface="Poppins" pitchFamily="34" charset="-120"/>
               </a:rPr>
-              <a:t>closed-won this week 34 deals · $131k (HubSpot); new MRR held at $12.1k QTD — movement register not refreshed</a:t>
+              <a:t>closed-won this week 34 deals · $131k (HubSpot); no new MRR invoiced in the week — Q3 holds at $12.1k = 43% of OKR2</a:t>
             </a:r>
             <a:endParaRPr lang="en-US" sz="900" dirty="0"/>
           </a:p>
@@ -27555,7 +27555,7 @@
                 <a:ea typeface="Poppins" pitchFamily="34" charset="-122"/>
                 <a:cs typeface="Poppins" pitchFamily="34" charset="-120"/>
               </a:rPr>
-              <a:t>  of $28k target · register as at 20 Sep</a:t>
+              <a:t>  of $28k target · register live</a:t>
             </a:r>
             <a:endParaRPr lang="en-US" sz="2400" dirty="0"/>
           </a:p>
@@ -27594,7 +27594,7 @@
                 <a:ea typeface="Poppins" pitchFamily="34" charset="-122"/>
                 <a:cs typeface="Poppins" pitchFamily="34" charset="-120"/>
               </a:rPr>
-              <a:t>refresh pending</a:t>
+              <a:t>nil this wk</a:t>
             </a:r>
             <a:endParaRPr lang="en-US" sz="950" dirty="0"/>
           </a:p>
@@ -28109,7 +28109,7 @@
                 <a:ea typeface="Poppins" pitchFamily="34" charset="-122"/>
                 <a:cs typeface="Poppins" pitchFamily="34" charset="-120"/>
               </a:rPr>
-              <a:t>NEW MRR ($/qtr) · register 20 Sep</a:t>
+              <a:t>NEW MRR ($/qtr) · register live</a:t>
             </a:r>
             <a:endParaRPr lang="en-US" sz="800" dirty="0"/>
           </a:p>
@@ -31884,7 +31884,7 @@
                 <a:ea typeface="Poppins" pitchFamily="34" charset="-122"/>
                 <a:cs typeface="Poppins" pitchFamily="34" charset="-120"/>
               </a:rPr>
-              <a:t>MRR = net new + expansion invoiced in Q3 (movement register, as at 20 Sep) · H&amp;L Pay net new $1,770/mo is tracked separately and never sits inside core MRR</a:t>
+              <a:t>MRR = net new + expansion invoiced in Q3 (movement register, live 27 Sep) · H&amp;L Pay net new $1,770/mo is tracked separately and never sits inside core MRR</a:t>
             </a:r>
             <a:endParaRPr lang="en-US" sz="700" dirty="0"/>
           </a:p>
@@ -32081,7 +32081,7 @@
             <a:r>
               <a:rPr lang="en-US" sz="900" b="1" dirty="0">
                 <a:solidFill>
-                  <a:srgbClr val="2C8394"/>
+                  <a:srgbClr val="B4552D"/>
                 </a:solidFill>
                 <a:latin typeface="Poppins" pitchFamily="34" charset="0"/>
                 <a:ea typeface="Poppins" pitchFamily="34" charset="-122"/>
@@ -32101,7 +32101,7 @@
                 <a:ea typeface="Poppins" pitchFamily="34" charset="-122"/>
                 <a:cs typeface="Poppins" pitchFamily="34" charset="-120"/>
               </a:rPr>
-              <a:t>New MRR was not refreshed this week. </a:t>
+              <a:t>New MRR did not move at all this week. </a:t>
             </a:r>
             <a:pPr indent="0" marL="0">
               <a:spcAft>
@@ -32118,7 +32118,7 @@
                 <a:ea typeface="Poppins" pitchFamily="34" charset="-122"/>
                 <a:cs typeface="Poppins" pitchFamily="34" charset="-120"/>
               </a:rPr>
-              <a:t>It is held at $12,129 (43% of the $28k OKR2) as at 20 Sep, against a 97% pace mark. The Sysnet extract's own subscription line moved +$592, which is a different measure and is not carried into MRR.</a:t>
+              <a:t>The register carries no new-MRR rows dated 21–27 Sep 2026, so Q3 stays at $12,129 — 43% of the $28k OKR2 against a 97% pace mark. The last entry was 18 Sep; the next dated ones are 28 Sep ($598, Piermount) and 30 Sep ($62) — inside Q3 but after this reporting week.</a:t>
             </a:r>
             <a:endParaRPr lang="en-US" sz="900" dirty="0"/>
           </a:p>
@@ -32166,8 +32166,8 @@
         </p:nvSpPr>
         <p:spPr>
           <a:xfrm>
-            <a:off x="7088429" y="6510528"/>
-            <a:ext cx="4689043" cy="256032"/>
+            <a:off x="7585862" y="6510528"/>
+            <a:ext cx="4191610" cy="256032"/>
           </a:xfrm>
           <a:prstGeom prst="roundRect">
             <a:avLst>
@@ -32188,8 +32188,8 @@
         </p:nvSpPr>
         <p:spPr>
           <a:xfrm>
-            <a:off x="7088429" y="6510528"/>
-            <a:ext cx="4689043" cy="256032"/>
+            <a:off x="7585862" y="6510528"/>
+            <a:ext cx="4191610" cy="256032"/>
           </a:xfrm>
           <a:prstGeom prst="rect">
             <a:avLst/>
@@ -32213,7 +32213,7 @@
                 <a:ea typeface="Poppins" pitchFamily="34" charset="-122"/>
                 <a:cs typeface="Poppins" pitchFamily="34" charset="-120"/>
               </a:rPr>
-              <a:t>Source: Sysnet extract 21–27 Sep + MRR movement register (as at 20 Sep)</a:t>
+              <a:t>Source: Sysnet extract 21–27 Sep + MRR movement register (live)</a:t>
             </a:r>
             <a:endParaRPr lang="en-US" sz="700" dirty="0"/>
           </a:p>
@@ -44782,7 +44782,7 @@
                 <a:ea typeface="Poppins" pitchFamily="34" charset="-122"/>
                 <a:cs typeface="Poppins" pitchFamily="34" charset="-120"/>
               </a:rPr>
-              <a:t>262 logos lost · register as at 20 Sep</a:t>
+              <a:t>262 logos lost · register live</a:t>
             </a:r>
             <a:endParaRPr lang="en-US" sz="780" dirty="0"/>
           </a:p>
@@ -47737,7 +47737,7 @@
                 <a:ea typeface="Poppins" pitchFamily="34" charset="-122"/>
                 <a:cs typeface="Poppins" pitchFamily="34" charset="-120"/>
               </a:rPr>
-              <a:t>Churn reads from the movement register (as at 20 Sep): $1.17M of ARR across 262 logos since 2025, plus $235k lost to contraction on accounts that stayed. Q3 net MRR is -$6.3k — new business is not covering it.</a:t>
+              <a:t>Churn reads from the movement register (live): $1.17M of ARR across 262 logos since 2025, plus $235k lost to contraction on accounts that stayed. Q3 net MRR is -$6.3k — new business is not covering it.</a:t>
             </a:r>
             <a:endParaRPr lang="en-US" sz="850" dirty="0"/>
           </a:p>
@@ -47886,8 +47886,8 @@
         </p:nvSpPr>
         <p:spPr>
           <a:xfrm>
-            <a:off x="6280099" y="6510528"/>
-            <a:ext cx="5497373" cy="256032"/>
+            <a:off x="7337146" y="6510528"/>
+            <a:ext cx="4440326" cy="256032"/>
           </a:xfrm>
           <a:prstGeom prst="roundRect">
             <a:avLst>
@@ -47908,8 +47908,8 @@
         </p:nvSpPr>
         <p:spPr>
           <a:xfrm>
-            <a:off x="6280099" y="6510528"/>
-            <a:ext cx="5497373" cy="256032"/>
+            <a:off x="7337146" y="6510528"/>
+            <a:ext cx="4440326" cy="256032"/>
           </a:xfrm>
           <a:prstGeom prst="rect">
             <a:avLst/>
@@ -47933,7 +47933,7 @@
                 <a:ea typeface="Poppins" pitchFamily="34" charset="-122"/>
                 <a:cs typeface="Poppins" pitchFamily="34" charset="-120"/>
               </a:rPr>
-              <a:t>Source: Finance Weekly Invoicing &amp; Creatio · register as at 20 Sep — refresh pending</a:t>
+              <a:t>Source: Finance Weekly Invoicing &amp; Creatio · movement register live</a:t>
             </a:r>
             <a:endParaRPr lang="en-US" sz="700" dirty="0"/>
           </a:p>

</xml_diff>

<commit_message>
Add net weekly MRR movement to the member table
The MRR block carried target, QTD and attainment but no weekly column -
only hardware had one - so there was nowhere to read the week's movement by
member. Added a NET Δ WK column, netted across all four register motions
(net new + expansion - churn - contraction), with the totals row and the
headline card carrying the same net figure.

Week 21-27 Sep:
  Jasmine  +899   BRG Granville Tavern
  Brett    +246   Coyote's Roadhouse +701, The Jungle Tingalpa churn -455
  Ho        +59   CSHG Walker Baker Evans
  net    +1,204   against +1,659 gross

The headline previously showed the gross +$1,659, which ignored the churn
in the same week; it now reads "+$1,204 net this wk" and the summary states
both figures. Columns across the member table were re-pitched to make room.

Co-Authored-By: Claude Opus 5 <noreply@anthropic.com>
Claude-Session: https://claude.ai/code/session_019YTPNjRj34XzLPLC9gKxc4
</commit_message>
<xml_diff>
--- a/exec-deck/output/H&L Weekly Update - WC 21 Sep 2026.pptx
+++ b/exec-deck/output/H&L Weekly Update - WC 21 Sep 2026.pptx
@@ -26259,7 +26259,7 @@
                 <a:ea typeface="Poppins" pitchFamily="34" charset="-122"/>
                 <a:cs typeface="Poppins" pitchFamily="34" charset="-120"/>
               </a:rPr>
-              <a:t>closed-won this week 34 deals · $131k (HubSpot); new MRR +$1.7k in the week · Q3 $15.1k = 54% of OKR2</a:t>
+              <a:t>closed-won this week 34 deals · $131k (HubSpot); net new MRR +$1.2k in the week (+$1.7k new, −$0.5k churn) · Q3 $15.1k = 54% of OKR2</a:t>
             </a:r>
             <a:endParaRPr lang="en-US" sz="900" dirty="0"/>
           </a:p>
@@ -27593,8 +27593,8 @@
         </p:nvSpPr>
         <p:spPr>
           <a:xfrm>
-            <a:off x="3794760" y="1371600"/>
-            <a:ext cx="2057400" cy="310896"/>
+            <a:off x="3611880" y="1371600"/>
+            <a:ext cx="2240280" cy="310896"/>
           </a:xfrm>
           <a:prstGeom prst="rect">
             <a:avLst/>
@@ -27618,7 +27618,7 @@
                 <a:ea typeface="Poppins" pitchFamily="34" charset="-122"/>
                 <a:cs typeface="Poppins" pitchFamily="34" charset="-120"/>
               </a:rPr>
-              <a:t>▲ +$1,659 this wk</a:t>
+              <a:t>▲ +$1,204 net this wk</a:t>
             </a:r>
             <a:endParaRPr lang="en-US" sz="950" dirty="0"/>
           </a:p>
@@ -28108,8 +28108,8 @@
         </p:nvSpPr>
         <p:spPr>
           <a:xfrm>
-            <a:off x="2221992" y="2724912"/>
-            <a:ext cx="2194560" cy="201168"/>
+            <a:off x="2002536" y="2724912"/>
+            <a:ext cx="2542032" cy="201168"/>
           </a:xfrm>
           <a:prstGeom prst="rect">
             <a:avLst/>
@@ -28147,8 +28147,8 @@
         </p:nvSpPr>
         <p:spPr>
           <a:xfrm>
-            <a:off x="4617720" y="2724912"/>
-            <a:ext cx="3383280" cy="201168"/>
+            <a:off x="4599432" y="2724912"/>
+            <a:ext cx="3200400" cy="201168"/>
           </a:xfrm>
           <a:prstGeom prst="rect">
             <a:avLst/>
@@ -28172,7 +28172,7 @@
                 <a:ea typeface="Poppins" pitchFamily="34" charset="-122"/>
                 <a:cs typeface="Poppins" pitchFamily="34" charset="-120"/>
               </a:rPr>
-              <a:t>HARDWARE ($/qtr) · extracts to 27 Sep · Δ wk = 21–27 Sep</a:t>
+              <a:t>HARDWARE ($/qtr) · extracts to 27 Sep</a:t>
             </a:r>
             <a:endParaRPr lang="en-US" sz="800" dirty="0"/>
           </a:p>
@@ -28187,7 +28187,7 @@
         <p:spPr>
           <a:xfrm>
             <a:off x="612648" y="2944368"/>
-            <a:ext cx="1554480" cy="182880"/>
+            <a:ext cx="1371600" cy="182880"/>
           </a:xfrm>
           <a:prstGeom prst="rect">
             <a:avLst/>
@@ -28225,8 +28225,8 @@
         </p:nvSpPr>
         <p:spPr>
           <a:xfrm>
-            <a:off x="2221992" y="2944368"/>
-            <a:ext cx="566928" cy="182880"/>
+            <a:off x="2002536" y="2944368"/>
+            <a:ext cx="475488" cy="182880"/>
           </a:xfrm>
           <a:prstGeom prst="rect">
             <a:avLst/>
@@ -28264,8 +28264,8 @@
         </p:nvSpPr>
         <p:spPr>
           <a:xfrm>
-            <a:off x="2807208" y="2944368"/>
-            <a:ext cx="566928" cy="182880"/>
+            <a:off x="2514600" y="2944368"/>
+            <a:ext cx="475488" cy="182880"/>
           </a:xfrm>
           <a:prstGeom prst="rect">
             <a:avLst/>
@@ -28303,8 +28303,8 @@
         </p:nvSpPr>
         <p:spPr>
           <a:xfrm>
-            <a:off x="3429000" y="2944368"/>
-            <a:ext cx="969264" cy="182880"/>
+            <a:off x="3044952" y="2944368"/>
+            <a:ext cx="914400" cy="182880"/>
           </a:xfrm>
           <a:prstGeom prst="rect">
             <a:avLst/>
@@ -28342,7 +28342,7 @@
         </p:nvSpPr>
         <p:spPr>
           <a:xfrm>
-            <a:off x="4617720" y="2944368"/>
+            <a:off x="3904488" y="2944368"/>
             <a:ext cx="640080" cy="182880"/>
           </a:xfrm>
           <a:prstGeom prst="rect">
@@ -28367,6 +28367,45 @@
                 <a:ea typeface="Poppins" pitchFamily="34" charset="-122"/>
                 <a:cs typeface="Poppins" pitchFamily="34" charset="-120"/>
               </a:rPr>
+              <a:t>NET Δ WK</a:t>
+            </a:r>
+            <a:endParaRPr lang="en-US" sz="750" dirty="0"/>
+          </a:p>
+        </p:txBody>
+      </p:sp>
+      <p:sp>
+        <p:nvSpPr>
+          <p:cNvPr id="38" name="Text 36"/>
+          <p:cNvSpPr txBox="1"/>
+          <p:nvPr/>
+        </p:nvSpPr>
+        <p:spPr>
+          <a:xfrm>
+            <a:off x="4599432" y="2944368"/>
+            <a:ext cx="548640" cy="182880"/>
+          </a:xfrm>
+          <a:prstGeom prst="rect">
+            <a:avLst/>
+          </a:prstGeom>
+          <a:noFill/>
+          <a:ln/>
+        </p:spPr>
+        <p:txBody>
+          <a:bodyPr wrap="square" lIns="0" tIns="0" rIns="0" bIns="0" rtlCol="0" anchor="ctr"/>
+          <a:lstStyle/>
+          <a:p>
+            <a:pPr algn="r" indent="0" marL="0">
+              <a:buNone/>
+            </a:pPr>
+            <a:r>
+              <a:rPr lang="en-US" sz="750" b="1" dirty="0">
+                <a:solidFill>
+                  <a:srgbClr val="8FA1AC"/>
+                </a:solidFill>
+                <a:latin typeface="Poppins" pitchFamily="34" charset="0"/>
+                <a:ea typeface="Poppins" pitchFamily="34" charset="-122"/>
+                <a:cs typeface="Poppins" pitchFamily="34" charset="-120"/>
+              </a:rPr>
               <a:t>TGT</a:t>
             </a:r>
             <a:endParaRPr lang="en-US" sz="750" dirty="0"/>
@@ -28375,14 +28414,14 @@
       </p:sp>
       <p:sp>
         <p:nvSpPr>
-          <p:cNvPr id="38" name="Text 36"/>
-          <p:cNvSpPr txBox="1"/>
-          <p:nvPr/>
-        </p:nvSpPr>
-        <p:spPr>
-          <a:xfrm>
-            <a:off x="5294376" y="2944368"/>
-            <a:ext cx="658368" cy="182880"/>
+          <p:cNvPr id="39" name="Text 37"/>
+          <p:cNvSpPr txBox="1"/>
+          <p:nvPr/>
+        </p:nvSpPr>
+        <p:spPr>
+          <a:xfrm>
+            <a:off x="5184648" y="2944368"/>
+            <a:ext cx="603504" cy="182880"/>
           </a:xfrm>
           <a:prstGeom prst="rect">
             <a:avLst/>
@@ -28414,14 +28453,14 @@
       </p:sp>
       <p:sp>
         <p:nvSpPr>
-          <p:cNvPr id="39" name="Text 37"/>
-          <p:cNvSpPr txBox="1"/>
-          <p:nvPr/>
-        </p:nvSpPr>
-        <p:spPr>
-          <a:xfrm>
-            <a:off x="6007608" y="2944368"/>
-            <a:ext cx="969264" cy="182880"/>
+          <p:cNvPr id="40" name="Text 38"/>
+          <p:cNvSpPr txBox="1"/>
+          <p:nvPr/>
+        </p:nvSpPr>
+        <p:spPr>
+          <a:xfrm>
+            <a:off x="5843016" y="2944368"/>
+            <a:ext cx="932688" cy="182880"/>
           </a:xfrm>
           <a:prstGeom prst="rect">
             <a:avLst/>
@@ -28453,14 +28492,14 @@
       </p:sp>
       <p:sp>
         <p:nvSpPr>
-          <p:cNvPr id="40" name="Text 38"/>
-          <p:cNvSpPr txBox="1"/>
-          <p:nvPr/>
-        </p:nvSpPr>
-        <p:spPr>
-          <a:xfrm>
-            <a:off x="7013448" y="2944368"/>
-            <a:ext cx="822960" cy="182880"/>
+          <p:cNvPr id="41" name="Text 39"/>
+          <p:cNvSpPr txBox="1"/>
+          <p:nvPr/>
+        </p:nvSpPr>
+        <p:spPr>
+          <a:xfrm>
+            <a:off x="6830568" y="2944368"/>
+            <a:ext cx="987552" cy="182880"/>
           </a:xfrm>
           <a:prstGeom prst="rect">
             <a:avLst/>
@@ -28492,7 +28531,7 @@
       </p:sp>
       <p:sp>
         <p:nvSpPr>
-          <p:cNvPr id="41" name="Shape 39"/>
+          <p:cNvPr id="42" name="Shape 40"/>
           <p:cNvSpPr/>
           <p:nvPr/>
         </p:nvSpPr>
@@ -28512,14 +28551,14 @@
       </p:sp>
       <p:sp>
         <p:nvSpPr>
-          <p:cNvPr id="42" name="Text 40"/>
+          <p:cNvPr id="43" name="Text 41"/>
           <p:cNvSpPr txBox="1"/>
           <p:nvPr/>
         </p:nvSpPr>
         <p:spPr>
           <a:xfrm>
             <a:off x="612648" y="3182112"/>
-            <a:ext cx="1591056" cy="315468"/>
+            <a:ext cx="1371600" cy="315468"/>
           </a:xfrm>
           <a:prstGeom prst="rect">
             <a:avLst/>
@@ -28551,14 +28590,14 @@
       </p:sp>
       <p:sp>
         <p:nvSpPr>
-          <p:cNvPr id="43" name="Text 41"/>
-          <p:cNvSpPr txBox="1"/>
-          <p:nvPr/>
-        </p:nvSpPr>
-        <p:spPr>
-          <a:xfrm>
-            <a:off x="2221992" y="3182112"/>
-            <a:ext cx="566928" cy="315468"/>
+          <p:cNvPr id="44" name="Text 42"/>
+          <p:cNvSpPr txBox="1"/>
+          <p:nvPr/>
+        </p:nvSpPr>
+        <p:spPr>
+          <a:xfrm>
+            <a:off x="2002536" y="3182112"/>
+            <a:ext cx="475488" cy="315468"/>
           </a:xfrm>
           <a:prstGeom prst="rect">
             <a:avLst/>
@@ -28590,14 +28629,14 @@
       </p:sp>
       <p:sp>
         <p:nvSpPr>
-          <p:cNvPr id="44" name="Text 42"/>
-          <p:cNvSpPr txBox="1"/>
-          <p:nvPr/>
-        </p:nvSpPr>
-        <p:spPr>
-          <a:xfrm>
-            <a:off x="2807208" y="3182112"/>
-            <a:ext cx="566928" cy="315468"/>
+          <p:cNvPr id="45" name="Text 43"/>
+          <p:cNvSpPr txBox="1"/>
+          <p:nvPr/>
+        </p:nvSpPr>
+        <p:spPr>
+          <a:xfrm>
+            <a:off x="2514600" y="3182112"/>
+            <a:ext cx="475488" cy="315468"/>
           </a:xfrm>
           <a:prstGeom prst="rect">
             <a:avLst/>
@@ -28629,14 +28668,14 @@
       </p:sp>
       <p:sp>
         <p:nvSpPr>
-          <p:cNvPr id="45" name="Shape 43"/>
-          <p:cNvSpPr/>
-          <p:nvPr/>
-        </p:nvSpPr>
-        <p:spPr>
-          <a:xfrm>
-            <a:off x="3465576" y="3294126"/>
-            <a:ext cx="731520" cy="100584"/>
+          <p:cNvPr id="46" name="Shape 44"/>
+          <p:cNvSpPr/>
+          <p:nvPr/>
+        </p:nvSpPr>
+        <p:spPr>
+          <a:xfrm>
+            <a:off x="3081528" y="3294126"/>
+            <a:ext cx="548640" cy="100584"/>
           </a:xfrm>
           <a:prstGeom prst="roundRect">
             <a:avLst>
@@ -28651,14 +28690,14 @@
       </p:sp>
       <p:sp>
         <p:nvSpPr>
-          <p:cNvPr id="46" name="Shape 44"/>
-          <p:cNvSpPr/>
-          <p:nvPr/>
-        </p:nvSpPr>
-        <p:spPr>
-          <a:xfrm>
-            <a:off x="3465576" y="3294126"/>
-            <a:ext cx="651053" cy="100584"/>
+          <p:cNvPr id="47" name="Shape 45"/>
+          <p:cNvSpPr/>
+          <p:nvPr/>
+        </p:nvSpPr>
+        <p:spPr>
+          <a:xfrm>
+            <a:off x="3081528" y="3294126"/>
+            <a:ext cx="488290" cy="100584"/>
           </a:xfrm>
           <a:prstGeom prst="roundRect">
             <a:avLst>
@@ -28673,13 +28712,13 @@
       </p:sp>
       <p:sp>
         <p:nvSpPr>
-          <p:cNvPr id="47" name="Shape 45"/>
-          <p:cNvSpPr/>
-          <p:nvPr/>
-        </p:nvSpPr>
-        <p:spPr>
-          <a:xfrm>
-            <a:off x="4165092" y="3248406"/>
+          <p:cNvPr id="48" name="Shape 46"/>
+          <p:cNvSpPr/>
+          <p:nvPr/>
+        </p:nvSpPr>
+        <p:spPr>
+          <a:xfrm>
+            <a:off x="3603650" y="3248406"/>
             <a:ext cx="20117" cy="192024"/>
           </a:xfrm>
           <a:prstGeom prst="rect">
@@ -28693,14 +28732,14 @@
       </p:sp>
       <p:sp>
         <p:nvSpPr>
-          <p:cNvPr id="48" name="Text 46"/>
-          <p:cNvSpPr txBox="1"/>
-          <p:nvPr/>
-        </p:nvSpPr>
-        <p:spPr>
-          <a:xfrm>
-            <a:off x="4233672" y="3182112"/>
-            <a:ext cx="384048" cy="315468"/>
+          <p:cNvPr id="49" name="Text 47"/>
+          <p:cNvSpPr txBox="1"/>
+          <p:nvPr/>
+        </p:nvSpPr>
+        <p:spPr>
+          <a:xfrm>
+            <a:off x="3630168" y="3182112"/>
+            <a:ext cx="329184" cy="315468"/>
           </a:xfrm>
           <a:prstGeom prst="rect">
             <a:avLst/>
@@ -28732,13 +28771,13 @@
       </p:sp>
       <p:sp>
         <p:nvSpPr>
-          <p:cNvPr id="49" name="Text 47"/>
-          <p:cNvSpPr txBox="1"/>
-          <p:nvPr/>
-        </p:nvSpPr>
-        <p:spPr>
-          <a:xfrm>
-            <a:off x="4617720" y="3182112"/>
+          <p:cNvPr id="50" name="Text 48"/>
+          <p:cNvSpPr txBox="1"/>
+          <p:nvPr/>
+        </p:nvSpPr>
+        <p:spPr>
+          <a:xfrm>
+            <a:off x="3904488" y="3182112"/>
             <a:ext cx="640080" cy="315468"/>
           </a:xfrm>
           <a:prstGeom prst="rect">
@@ -28757,6 +28796,45 @@
             <a:r>
               <a:rPr lang="en-US" sz="850" dirty="0">
                 <a:solidFill>
+                  <a:srgbClr val="8FA1AC"/>
+                </a:solidFill>
+                <a:latin typeface="Poppins" pitchFamily="34" charset="0"/>
+                <a:ea typeface="Poppins" pitchFamily="34" charset="-122"/>
+                <a:cs typeface="Poppins" pitchFamily="34" charset="-120"/>
+              </a:rPr>
+              <a:t>—</a:t>
+            </a:r>
+            <a:endParaRPr lang="en-US" sz="850" dirty="0"/>
+          </a:p>
+        </p:txBody>
+      </p:sp>
+      <p:sp>
+        <p:nvSpPr>
+          <p:cNvPr id="51" name="Text 49"/>
+          <p:cNvSpPr txBox="1"/>
+          <p:nvPr/>
+        </p:nvSpPr>
+        <p:spPr>
+          <a:xfrm>
+            <a:off x="4599432" y="3182112"/>
+            <a:ext cx="548640" cy="315468"/>
+          </a:xfrm>
+          <a:prstGeom prst="rect">
+            <a:avLst/>
+          </a:prstGeom>
+          <a:noFill/>
+          <a:ln/>
+        </p:spPr>
+        <p:txBody>
+          <a:bodyPr wrap="square" lIns="0" tIns="0" rIns="0" bIns="0" rtlCol="0" anchor="ctr"/>
+          <a:lstStyle/>
+          <a:p>
+            <a:pPr algn="r" indent="0" marL="0">
+              <a:buNone/>
+            </a:pPr>
+            <a:r>
+              <a:rPr lang="en-US" sz="850" dirty="0">
+                <a:solidFill>
                   <a:srgbClr val="5E7280"/>
                 </a:solidFill>
                 <a:latin typeface="Poppins" pitchFamily="34" charset="0"/>
@@ -28771,14 +28849,14 @@
       </p:sp>
       <p:sp>
         <p:nvSpPr>
-          <p:cNvPr id="50" name="Text 48"/>
-          <p:cNvSpPr txBox="1"/>
-          <p:nvPr/>
-        </p:nvSpPr>
-        <p:spPr>
-          <a:xfrm>
-            <a:off x="5294376" y="3182112"/>
-            <a:ext cx="658368" cy="315468"/>
+          <p:cNvPr id="52" name="Text 50"/>
+          <p:cNvSpPr txBox="1"/>
+          <p:nvPr/>
+        </p:nvSpPr>
+        <p:spPr>
+          <a:xfrm>
+            <a:off x="5184648" y="3182112"/>
+            <a:ext cx="603504" cy="315468"/>
           </a:xfrm>
           <a:prstGeom prst="rect">
             <a:avLst/>
@@ -28810,14 +28888,14 @@
       </p:sp>
       <p:sp>
         <p:nvSpPr>
-          <p:cNvPr id="51" name="Shape 49"/>
-          <p:cNvSpPr/>
-          <p:nvPr/>
-        </p:nvSpPr>
-        <p:spPr>
-          <a:xfrm>
-            <a:off x="6044184" y="3294126"/>
-            <a:ext cx="731520" cy="100584"/>
+          <p:cNvPr id="53" name="Shape 51"/>
+          <p:cNvSpPr/>
+          <p:nvPr/>
+        </p:nvSpPr>
+        <p:spPr>
+          <a:xfrm>
+            <a:off x="5879592" y="3294126"/>
+            <a:ext cx="566928" cy="100584"/>
           </a:xfrm>
           <a:prstGeom prst="roundRect">
             <a:avLst>
@@ -28832,14 +28910,14 @@
       </p:sp>
       <p:sp>
         <p:nvSpPr>
-          <p:cNvPr id="52" name="Shape 50"/>
-          <p:cNvSpPr/>
-          <p:nvPr/>
-        </p:nvSpPr>
-        <p:spPr>
-          <a:xfrm>
-            <a:off x="6044184" y="3294126"/>
-            <a:ext cx="270662" cy="100584"/>
+          <p:cNvPr id="54" name="Shape 52"/>
+          <p:cNvSpPr/>
+          <p:nvPr/>
+        </p:nvSpPr>
+        <p:spPr>
+          <a:xfrm>
+            <a:off x="5879592" y="3294126"/>
+            <a:ext cx="209763" cy="100584"/>
           </a:xfrm>
           <a:prstGeom prst="roundRect">
             <a:avLst>
@@ -28854,13 +28932,13 @@
       </p:sp>
       <p:sp>
         <p:nvSpPr>
-          <p:cNvPr id="53" name="Shape 51"/>
-          <p:cNvSpPr/>
-          <p:nvPr/>
-        </p:nvSpPr>
-        <p:spPr>
-          <a:xfrm>
-            <a:off x="6743700" y="3248406"/>
+          <p:cNvPr id="55" name="Shape 53"/>
+          <p:cNvSpPr/>
+          <p:nvPr/>
+        </p:nvSpPr>
+        <p:spPr>
+          <a:xfrm>
+            <a:off x="6419454" y="3248406"/>
             <a:ext cx="20117" cy="192024"/>
           </a:xfrm>
           <a:prstGeom prst="rect">
@@ -28874,14 +28952,14 @@
       </p:sp>
       <p:sp>
         <p:nvSpPr>
-          <p:cNvPr id="54" name="Text 52"/>
-          <p:cNvSpPr txBox="1"/>
-          <p:nvPr/>
-        </p:nvSpPr>
-        <p:spPr>
-          <a:xfrm>
-            <a:off x="6812280" y="3182112"/>
-            <a:ext cx="384048" cy="315468"/>
+          <p:cNvPr id="56" name="Text 54"/>
+          <p:cNvSpPr txBox="1"/>
+          <p:nvPr/>
+        </p:nvSpPr>
+        <p:spPr>
+          <a:xfrm>
+            <a:off x="6464808" y="3182112"/>
+            <a:ext cx="329184" cy="315468"/>
           </a:xfrm>
           <a:prstGeom prst="rect">
             <a:avLst/>
@@ -28913,14 +28991,14 @@
       </p:sp>
       <p:sp>
         <p:nvSpPr>
-          <p:cNvPr id="55" name="Text 53"/>
-          <p:cNvSpPr txBox="1"/>
-          <p:nvPr/>
-        </p:nvSpPr>
-        <p:spPr>
-          <a:xfrm>
-            <a:off x="7013448" y="3182112"/>
-            <a:ext cx="822960" cy="315468"/>
+          <p:cNvPr id="57" name="Text 55"/>
+          <p:cNvSpPr txBox="1"/>
+          <p:nvPr/>
+        </p:nvSpPr>
+        <p:spPr>
+          <a:xfrm>
+            <a:off x="6830568" y="3182112"/>
+            <a:ext cx="987552" cy="315468"/>
           </a:xfrm>
           <a:prstGeom prst="rect">
             <a:avLst/>
@@ -28952,7 +29030,7 @@
       </p:sp>
       <p:sp>
         <p:nvSpPr>
-          <p:cNvPr id="56" name="Shape 54"/>
+          <p:cNvPr id="58" name="Shape 56"/>
           <p:cNvSpPr/>
           <p:nvPr/>
         </p:nvSpPr>
@@ -28972,14 +29050,14 @@
       </p:sp>
       <p:sp>
         <p:nvSpPr>
-          <p:cNvPr id="57" name="Text 55"/>
+          <p:cNvPr id="59" name="Text 57"/>
           <p:cNvSpPr txBox="1"/>
           <p:nvPr/>
         </p:nvSpPr>
         <p:spPr>
           <a:xfrm>
             <a:off x="612648" y="3497580"/>
-            <a:ext cx="1591056" cy="315468"/>
+            <a:ext cx="1371600" cy="315468"/>
           </a:xfrm>
           <a:prstGeom prst="rect">
             <a:avLst/>
@@ -29011,14 +29089,14 @@
       </p:sp>
       <p:sp>
         <p:nvSpPr>
-          <p:cNvPr id="58" name="Text 56"/>
-          <p:cNvSpPr txBox="1"/>
-          <p:nvPr/>
-        </p:nvSpPr>
-        <p:spPr>
-          <a:xfrm>
-            <a:off x="2221992" y="3497580"/>
-            <a:ext cx="566928" cy="315468"/>
+          <p:cNvPr id="60" name="Text 58"/>
+          <p:cNvSpPr txBox="1"/>
+          <p:nvPr/>
+        </p:nvSpPr>
+        <p:spPr>
+          <a:xfrm>
+            <a:off x="2002536" y="3497580"/>
+            <a:ext cx="475488" cy="315468"/>
           </a:xfrm>
           <a:prstGeom prst="rect">
             <a:avLst/>
@@ -29050,14 +29128,14 @@
       </p:sp>
       <p:sp>
         <p:nvSpPr>
-          <p:cNvPr id="59" name="Text 57"/>
-          <p:cNvSpPr txBox="1"/>
-          <p:nvPr/>
-        </p:nvSpPr>
-        <p:spPr>
-          <a:xfrm>
-            <a:off x="2807208" y="3497580"/>
-            <a:ext cx="566928" cy="315468"/>
+          <p:cNvPr id="61" name="Text 59"/>
+          <p:cNvSpPr txBox="1"/>
+          <p:nvPr/>
+        </p:nvSpPr>
+        <p:spPr>
+          <a:xfrm>
+            <a:off x="2514600" y="3497580"/>
+            <a:ext cx="475488" cy="315468"/>
           </a:xfrm>
           <a:prstGeom prst="rect">
             <a:avLst/>
@@ -29089,14 +29167,14 @@
       </p:sp>
       <p:sp>
         <p:nvSpPr>
-          <p:cNvPr id="60" name="Shape 58"/>
-          <p:cNvSpPr/>
-          <p:nvPr/>
-        </p:nvSpPr>
-        <p:spPr>
-          <a:xfrm>
-            <a:off x="3465576" y="3609594"/>
-            <a:ext cx="731520" cy="100584"/>
+          <p:cNvPr id="62" name="Shape 60"/>
+          <p:cNvSpPr/>
+          <p:nvPr/>
+        </p:nvSpPr>
+        <p:spPr>
+          <a:xfrm>
+            <a:off x="3081528" y="3609594"/>
+            <a:ext cx="548640" cy="100584"/>
           </a:xfrm>
           <a:prstGeom prst="roundRect">
             <a:avLst>
@@ -29111,14 +29189,14 @@
       </p:sp>
       <p:sp>
         <p:nvSpPr>
-          <p:cNvPr id="61" name="Shape 59"/>
-          <p:cNvSpPr/>
-          <p:nvPr/>
-        </p:nvSpPr>
-        <p:spPr>
-          <a:xfrm>
-            <a:off x="3465576" y="3609594"/>
-            <a:ext cx="592531" cy="100584"/>
+          <p:cNvPr id="63" name="Shape 61"/>
+          <p:cNvSpPr/>
+          <p:nvPr/>
+        </p:nvSpPr>
+        <p:spPr>
+          <a:xfrm>
+            <a:off x="3081528" y="3609594"/>
+            <a:ext cx="444398" cy="100584"/>
           </a:xfrm>
           <a:prstGeom prst="roundRect">
             <a:avLst>
@@ -29133,13 +29211,13 @@
       </p:sp>
       <p:sp>
         <p:nvSpPr>
-          <p:cNvPr id="62" name="Shape 60"/>
-          <p:cNvSpPr/>
-          <p:nvPr/>
-        </p:nvSpPr>
-        <p:spPr>
-          <a:xfrm>
-            <a:off x="4165092" y="3563874"/>
+          <p:cNvPr id="64" name="Shape 62"/>
+          <p:cNvSpPr/>
+          <p:nvPr/>
+        </p:nvSpPr>
+        <p:spPr>
+          <a:xfrm>
+            <a:off x="3603650" y="3563874"/>
             <a:ext cx="20117" cy="192024"/>
           </a:xfrm>
           <a:prstGeom prst="rect">
@@ -29153,14 +29231,14 @@
       </p:sp>
       <p:sp>
         <p:nvSpPr>
-          <p:cNvPr id="63" name="Text 61"/>
-          <p:cNvSpPr txBox="1"/>
-          <p:nvPr/>
-        </p:nvSpPr>
-        <p:spPr>
-          <a:xfrm>
-            <a:off x="4233672" y="3497580"/>
-            <a:ext cx="384048" cy="315468"/>
+          <p:cNvPr id="65" name="Text 63"/>
+          <p:cNvSpPr txBox="1"/>
+          <p:nvPr/>
+        </p:nvSpPr>
+        <p:spPr>
+          <a:xfrm>
+            <a:off x="3630168" y="3497580"/>
+            <a:ext cx="329184" cy="315468"/>
           </a:xfrm>
           <a:prstGeom prst="rect">
             <a:avLst/>
@@ -29192,13 +29270,13 @@
       </p:sp>
       <p:sp>
         <p:nvSpPr>
-          <p:cNvPr id="64" name="Text 62"/>
-          <p:cNvSpPr txBox="1"/>
-          <p:nvPr/>
-        </p:nvSpPr>
-        <p:spPr>
-          <a:xfrm>
-            <a:off x="4617720" y="3497580"/>
+          <p:cNvPr id="66" name="Text 64"/>
+          <p:cNvSpPr txBox="1"/>
+          <p:nvPr/>
+        </p:nvSpPr>
+        <p:spPr>
+          <a:xfrm>
+            <a:off x="3904488" y="3497580"/>
             <a:ext cx="640080" cy="315468"/>
           </a:xfrm>
           <a:prstGeom prst="rect">
@@ -29215,6 +29293,45 @@
               <a:buNone/>
             </a:pPr>
             <a:r>
+              <a:rPr lang="en-US" sz="850" b="1" dirty="0">
+                <a:solidFill>
+                  <a:srgbClr val="3D8F5F"/>
+                </a:solidFill>
+                <a:latin typeface="Poppins" pitchFamily="34" charset="0"/>
+                <a:ea typeface="Poppins" pitchFamily="34" charset="-122"/>
+                <a:cs typeface="Poppins" pitchFamily="34" charset="-120"/>
+              </a:rPr>
+              <a:t>+246</a:t>
+            </a:r>
+            <a:endParaRPr lang="en-US" sz="850" dirty="0"/>
+          </a:p>
+        </p:txBody>
+      </p:sp>
+      <p:sp>
+        <p:nvSpPr>
+          <p:cNvPr id="67" name="Text 65"/>
+          <p:cNvSpPr txBox="1"/>
+          <p:nvPr/>
+        </p:nvSpPr>
+        <p:spPr>
+          <a:xfrm>
+            <a:off x="4599432" y="3497580"/>
+            <a:ext cx="548640" cy="315468"/>
+          </a:xfrm>
+          <a:prstGeom prst="rect">
+            <a:avLst/>
+          </a:prstGeom>
+          <a:noFill/>
+          <a:ln/>
+        </p:spPr>
+        <p:txBody>
+          <a:bodyPr wrap="square" lIns="0" tIns="0" rIns="0" bIns="0" rtlCol="0" anchor="ctr"/>
+          <a:lstStyle/>
+          <a:p>
+            <a:pPr algn="r" indent="0" marL="0">
+              <a:buNone/>
+            </a:pPr>
+            <a:r>
               <a:rPr lang="en-US" sz="850" dirty="0">
                 <a:solidFill>
                   <a:srgbClr val="5E7280"/>
@@ -29231,14 +29348,14 @@
       </p:sp>
       <p:sp>
         <p:nvSpPr>
-          <p:cNvPr id="65" name="Text 63"/>
-          <p:cNvSpPr txBox="1"/>
-          <p:nvPr/>
-        </p:nvSpPr>
-        <p:spPr>
-          <a:xfrm>
-            <a:off x="5294376" y="3497580"/>
-            <a:ext cx="658368" cy="315468"/>
+          <p:cNvPr id="68" name="Text 66"/>
+          <p:cNvSpPr txBox="1"/>
+          <p:nvPr/>
+        </p:nvSpPr>
+        <p:spPr>
+          <a:xfrm>
+            <a:off x="5184648" y="3497580"/>
+            <a:ext cx="603504" cy="315468"/>
           </a:xfrm>
           <a:prstGeom prst="rect">
             <a:avLst/>
@@ -29270,14 +29387,14 @@
       </p:sp>
       <p:sp>
         <p:nvSpPr>
-          <p:cNvPr id="66" name="Shape 64"/>
-          <p:cNvSpPr/>
-          <p:nvPr/>
-        </p:nvSpPr>
-        <p:spPr>
-          <a:xfrm>
-            <a:off x="6044184" y="3609594"/>
-            <a:ext cx="731520" cy="100584"/>
+          <p:cNvPr id="69" name="Shape 67"/>
+          <p:cNvSpPr/>
+          <p:nvPr/>
+        </p:nvSpPr>
+        <p:spPr>
+          <a:xfrm>
+            <a:off x="5879592" y="3609594"/>
+            <a:ext cx="566928" cy="100584"/>
           </a:xfrm>
           <a:prstGeom prst="roundRect">
             <a:avLst>
@@ -29292,14 +29409,14 @@
       </p:sp>
       <p:sp>
         <p:nvSpPr>
-          <p:cNvPr id="67" name="Shape 65"/>
-          <p:cNvSpPr/>
-          <p:nvPr/>
-        </p:nvSpPr>
-        <p:spPr>
-          <a:xfrm>
-            <a:off x="6044184" y="3609594"/>
-            <a:ext cx="446227" cy="100584"/>
+          <p:cNvPr id="70" name="Shape 68"/>
+          <p:cNvSpPr/>
+          <p:nvPr/>
+        </p:nvSpPr>
+        <p:spPr>
+          <a:xfrm>
+            <a:off x="5879592" y="3609594"/>
+            <a:ext cx="345826" cy="100584"/>
           </a:xfrm>
           <a:prstGeom prst="roundRect">
             <a:avLst>
@@ -29314,13 +29431,13 @@
       </p:sp>
       <p:sp>
         <p:nvSpPr>
-          <p:cNvPr id="68" name="Shape 66"/>
-          <p:cNvSpPr/>
-          <p:nvPr/>
-        </p:nvSpPr>
-        <p:spPr>
-          <a:xfrm>
-            <a:off x="6743700" y="3563874"/>
+          <p:cNvPr id="71" name="Shape 69"/>
+          <p:cNvSpPr/>
+          <p:nvPr/>
+        </p:nvSpPr>
+        <p:spPr>
+          <a:xfrm>
+            <a:off x="6419454" y="3563874"/>
             <a:ext cx="20117" cy="192024"/>
           </a:xfrm>
           <a:prstGeom prst="rect">
@@ -29334,14 +29451,14 @@
       </p:sp>
       <p:sp>
         <p:nvSpPr>
-          <p:cNvPr id="69" name="Text 67"/>
-          <p:cNvSpPr txBox="1"/>
-          <p:nvPr/>
-        </p:nvSpPr>
-        <p:spPr>
-          <a:xfrm>
-            <a:off x="6812280" y="3497580"/>
-            <a:ext cx="384048" cy="315468"/>
+          <p:cNvPr id="72" name="Text 70"/>
+          <p:cNvSpPr txBox="1"/>
+          <p:nvPr/>
+        </p:nvSpPr>
+        <p:spPr>
+          <a:xfrm>
+            <a:off x="6464808" y="3497580"/>
+            <a:ext cx="329184" cy="315468"/>
           </a:xfrm>
           <a:prstGeom prst="rect">
             <a:avLst/>
@@ -29373,14 +29490,14 @@
       </p:sp>
       <p:sp>
         <p:nvSpPr>
-          <p:cNvPr id="70" name="Text 68"/>
-          <p:cNvSpPr txBox="1"/>
-          <p:nvPr/>
-        </p:nvSpPr>
-        <p:spPr>
-          <a:xfrm>
-            <a:off x="7013448" y="3497580"/>
-            <a:ext cx="822960" cy="315468"/>
+          <p:cNvPr id="73" name="Text 71"/>
+          <p:cNvSpPr txBox="1"/>
+          <p:nvPr/>
+        </p:nvSpPr>
+        <p:spPr>
+          <a:xfrm>
+            <a:off x="6830568" y="3497580"/>
+            <a:ext cx="987552" cy="315468"/>
           </a:xfrm>
           <a:prstGeom prst="rect">
             <a:avLst/>
@@ -29412,7 +29529,7 @@
       </p:sp>
       <p:sp>
         <p:nvSpPr>
-          <p:cNvPr id="71" name="Shape 69"/>
+          <p:cNvPr id="74" name="Shape 72"/>
           <p:cNvSpPr/>
           <p:nvPr/>
         </p:nvSpPr>
@@ -29432,14 +29549,14 @@
       </p:sp>
       <p:sp>
         <p:nvSpPr>
-          <p:cNvPr id="72" name="Text 70"/>
+          <p:cNvPr id="75" name="Text 73"/>
           <p:cNvSpPr txBox="1"/>
           <p:nvPr/>
         </p:nvSpPr>
         <p:spPr>
           <a:xfrm>
             <a:off x="612648" y="3813048"/>
-            <a:ext cx="1591056" cy="315468"/>
+            <a:ext cx="1371600" cy="315468"/>
           </a:xfrm>
           <a:prstGeom prst="rect">
             <a:avLst/>
@@ -29471,14 +29588,14 @@
       </p:sp>
       <p:sp>
         <p:nvSpPr>
-          <p:cNvPr id="73" name="Text 71"/>
-          <p:cNvSpPr txBox="1"/>
-          <p:nvPr/>
-        </p:nvSpPr>
-        <p:spPr>
-          <a:xfrm>
-            <a:off x="2221992" y="3813048"/>
-            <a:ext cx="566928" cy="315468"/>
+          <p:cNvPr id="76" name="Text 74"/>
+          <p:cNvSpPr txBox="1"/>
+          <p:nvPr/>
+        </p:nvSpPr>
+        <p:spPr>
+          <a:xfrm>
+            <a:off x="2002536" y="3813048"/>
+            <a:ext cx="475488" cy="315468"/>
           </a:xfrm>
           <a:prstGeom prst="rect">
             <a:avLst/>
@@ -29510,14 +29627,14 @@
       </p:sp>
       <p:sp>
         <p:nvSpPr>
-          <p:cNvPr id="74" name="Text 72"/>
-          <p:cNvSpPr txBox="1"/>
-          <p:nvPr/>
-        </p:nvSpPr>
-        <p:spPr>
-          <a:xfrm>
-            <a:off x="2807208" y="3813048"/>
-            <a:ext cx="566928" cy="315468"/>
+          <p:cNvPr id="77" name="Text 75"/>
+          <p:cNvSpPr txBox="1"/>
+          <p:nvPr/>
+        </p:nvSpPr>
+        <p:spPr>
+          <a:xfrm>
+            <a:off x="2514600" y="3813048"/>
+            <a:ext cx="475488" cy="315468"/>
           </a:xfrm>
           <a:prstGeom prst="rect">
             <a:avLst/>
@@ -29549,14 +29666,14 @@
       </p:sp>
       <p:sp>
         <p:nvSpPr>
-          <p:cNvPr id="75" name="Shape 73"/>
-          <p:cNvSpPr/>
-          <p:nvPr/>
-        </p:nvSpPr>
-        <p:spPr>
-          <a:xfrm>
-            <a:off x="3465576" y="3925062"/>
-            <a:ext cx="731520" cy="100584"/>
+          <p:cNvPr id="78" name="Shape 76"/>
+          <p:cNvSpPr/>
+          <p:nvPr/>
+        </p:nvSpPr>
+        <p:spPr>
+          <a:xfrm>
+            <a:off x="3081528" y="3925062"/>
+            <a:ext cx="548640" cy="100584"/>
           </a:xfrm>
           <a:prstGeom prst="roundRect">
             <a:avLst>
@@ -29571,14 +29688,14 @@
       </p:sp>
       <p:sp>
         <p:nvSpPr>
-          <p:cNvPr id="76" name="Shape 74"/>
-          <p:cNvSpPr/>
-          <p:nvPr/>
-        </p:nvSpPr>
-        <p:spPr>
-          <a:xfrm>
-            <a:off x="3465576" y="3925062"/>
-            <a:ext cx="358445" cy="100584"/>
+          <p:cNvPr id="79" name="Shape 77"/>
+          <p:cNvSpPr/>
+          <p:nvPr/>
+        </p:nvSpPr>
+        <p:spPr>
+          <a:xfrm>
+            <a:off x="3081528" y="3925062"/>
+            <a:ext cx="268834" cy="100584"/>
           </a:xfrm>
           <a:prstGeom prst="roundRect">
             <a:avLst>
@@ -29593,13 +29710,13 @@
       </p:sp>
       <p:sp>
         <p:nvSpPr>
-          <p:cNvPr id="77" name="Shape 75"/>
-          <p:cNvSpPr/>
-          <p:nvPr/>
-        </p:nvSpPr>
-        <p:spPr>
-          <a:xfrm>
-            <a:off x="4165092" y="3879342"/>
+          <p:cNvPr id="80" name="Shape 78"/>
+          <p:cNvSpPr/>
+          <p:nvPr/>
+        </p:nvSpPr>
+        <p:spPr>
+          <a:xfrm>
+            <a:off x="3603650" y="3879342"/>
             <a:ext cx="20117" cy="192024"/>
           </a:xfrm>
           <a:prstGeom prst="rect">
@@ -29613,14 +29730,14 @@
       </p:sp>
       <p:sp>
         <p:nvSpPr>
-          <p:cNvPr id="78" name="Text 76"/>
-          <p:cNvSpPr txBox="1"/>
-          <p:nvPr/>
-        </p:nvSpPr>
-        <p:spPr>
-          <a:xfrm>
-            <a:off x="4233672" y="3813048"/>
-            <a:ext cx="384048" cy="315468"/>
+          <p:cNvPr id="81" name="Text 79"/>
+          <p:cNvSpPr txBox="1"/>
+          <p:nvPr/>
+        </p:nvSpPr>
+        <p:spPr>
+          <a:xfrm>
+            <a:off x="3630168" y="3813048"/>
+            <a:ext cx="329184" cy="315468"/>
           </a:xfrm>
           <a:prstGeom prst="rect">
             <a:avLst/>
@@ -29652,13 +29769,13 @@
       </p:sp>
       <p:sp>
         <p:nvSpPr>
-          <p:cNvPr id="79" name="Text 77"/>
-          <p:cNvSpPr txBox="1"/>
-          <p:nvPr/>
-        </p:nvSpPr>
-        <p:spPr>
-          <a:xfrm>
-            <a:off x="4617720" y="3813048"/>
+          <p:cNvPr id="82" name="Text 80"/>
+          <p:cNvSpPr txBox="1"/>
+          <p:nvPr/>
+        </p:nvSpPr>
+        <p:spPr>
+          <a:xfrm>
+            <a:off x="3904488" y="3813048"/>
             <a:ext cx="640080" cy="315468"/>
           </a:xfrm>
           <a:prstGeom prst="rect">
@@ -29677,6 +29794,45 @@
             <a:r>
               <a:rPr lang="en-US" sz="850" dirty="0">
                 <a:solidFill>
+                  <a:srgbClr val="8FA1AC"/>
+                </a:solidFill>
+                <a:latin typeface="Poppins" pitchFamily="34" charset="0"/>
+                <a:ea typeface="Poppins" pitchFamily="34" charset="-122"/>
+                <a:cs typeface="Poppins" pitchFamily="34" charset="-120"/>
+              </a:rPr>
+              <a:t>—</a:t>
+            </a:r>
+            <a:endParaRPr lang="en-US" sz="850" dirty="0"/>
+          </a:p>
+        </p:txBody>
+      </p:sp>
+      <p:sp>
+        <p:nvSpPr>
+          <p:cNvPr id="83" name="Text 81"/>
+          <p:cNvSpPr txBox="1"/>
+          <p:nvPr/>
+        </p:nvSpPr>
+        <p:spPr>
+          <a:xfrm>
+            <a:off x="4599432" y="3813048"/>
+            <a:ext cx="548640" cy="315468"/>
+          </a:xfrm>
+          <a:prstGeom prst="rect">
+            <a:avLst/>
+          </a:prstGeom>
+          <a:noFill/>
+          <a:ln/>
+        </p:spPr>
+        <p:txBody>
+          <a:bodyPr wrap="square" lIns="0" tIns="0" rIns="0" bIns="0" rtlCol="0" anchor="ctr"/>
+          <a:lstStyle/>
+          <a:p>
+            <a:pPr algn="r" indent="0" marL="0">
+              <a:buNone/>
+            </a:pPr>
+            <a:r>
+              <a:rPr lang="en-US" sz="850" dirty="0">
+                <a:solidFill>
                   <a:srgbClr val="5E7280"/>
                 </a:solidFill>
                 <a:latin typeface="Poppins" pitchFamily="34" charset="0"/>
@@ -29691,14 +29847,14 @@
       </p:sp>
       <p:sp>
         <p:nvSpPr>
-          <p:cNvPr id="80" name="Text 78"/>
-          <p:cNvSpPr txBox="1"/>
-          <p:nvPr/>
-        </p:nvSpPr>
-        <p:spPr>
-          <a:xfrm>
-            <a:off x="5294376" y="3813048"/>
-            <a:ext cx="658368" cy="315468"/>
+          <p:cNvPr id="84" name="Text 82"/>
+          <p:cNvSpPr txBox="1"/>
+          <p:nvPr/>
+        </p:nvSpPr>
+        <p:spPr>
+          <a:xfrm>
+            <a:off x="5184648" y="3813048"/>
+            <a:ext cx="603504" cy="315468"/>
           </a:xfrm>
           <a:prstGeom prst="rect">
             <a:avLst/>
@@ -29730,14 +29886,14 @@
       </p:sp>
       <p:sp>
         <p:nvSpPr>
-          <p:cNvPr id="81" name="Shape 79"/>
-          <p:cNvSpPr/>
-          <p:nvPr/>
-        </p:nvSpPr>
-        <p:spPr>
-          <a:xfrm>
-            <a:off x="6044184" y="3925062"/>
-            <a:ext cx="731520" cy="100584"/>
+          <p:cNvPr id="85" name="Shape 83"/>
+          <p:cNvSpPr/>
+          <p:nvPr/>
+        </p:nvSpPr>
+        <p:spPr>
+          <a:xfrm>
+            <a:off x="5879592" y="3925062"/>
+            <a:ext cx="566928" cy="100584"/>
           </a:xfrm>
           <a:prstGeom prst="roundRect">
             <a:avLst>
@@ -29752,14 +29908,14 @@
       </p:sp>
       <p:sp>
         <p:nvSpPr>
-          <p:cNvPr id="82" name="Shape 80"/>
-          <p:cNvSpPr/>
-          <p:nvPr/>
-        </p:nvSpPr>
-        <p:spPr>
-          <a:xfrm>
-            <a:off x="6044184" y="3925062"/>
-            <a:ext cx="241402" cy="100584"/>
+          <p:cNvPr id="86" name="Shape 84"/>
+          <p:cNvSpPr/>
+          <p:nvPr/>
+        </p:nvSpPr>
+        <p:spPr>
+          <a:xfrm>
+            <a:off x="5879592" y="3925062"/>
+            <a:ext cx="187086" cy="100584"/>
           </a:xfrm>
           <a:prstGeom prst="roundRect">
             <a:avLst>
@@ -29774,13 +29930,13 @@
       </p:sp>
       <p:sp>
         <p:nvSpPr>
-          <p:cNvPr id="83" name="Shape 81"/>
-          <p:cNvSpPr/>
-          <p:nvPr/>
-        </p:nvSpPr>
-        <p:spPr>
-          <a:xfrm>
-            <a:off x="6743700" y="3879342"/>
+          <p:cNvPr id="87" name="Shape 85"/>
+          <p:cNvSpPr/>
+          <p:nvPr/>
+        </p:nvSpPr>
+        <p:spPr>
+          <a:xfrm>
+            <a:off x="6419454" y="3879342"/>
             <a:ext cx="20117" cy="192024"/>
           </a:xfrm>
           <a:prstGeom prst="rect">
@@ -29794,14 +29950,14 @@
       </p:sp>
       <p:sp>
         <p:nvSpPr>
-          <p:cNvPr id="84" name="Text 82"/>
-          <p:cNvSpPr txBox="1"/>
-          <p:nvPr/>
-        </p:nvSpPr>
-        <p:spPr>
-          <a:xfrm>
-            <a:off x="6812280" y="3813048"/>
-            <a:ext cx="384048" cy="315468"/>
+          <p:cNvPr id="88" name="Text 86"/>
+          <p:cNvSpPr txBox="1"/>
+          <p:nvPr/>
+        </p:nvSpPr>
+        <p:spPr>
+          <a:xfrm>
+            <a:off x="6464808" y="3813048"/>
+            <a:ext cx="329184" cy="315468"/>
           </a:xfrm>
           <a:prstGeom prst="rect">
             <a:avLst/>
@@ -29833,14 +29989,14 @@
       </p:sp>
       <p:sp>
         <p:nvSpPr>
-          <p:cNvPr id="85" name="Text 83"/>
-          <p:cNvSpPr txBox="1"/>
-          <p:nvPr/>
-        </p:nvSpPr>
-        <p:spPr>
-          <a:xfrm>
-            <a:off x="7013448" y="3813048"/>
-            <a:ext cx="822960" cy="315468"/>
+          <p:cNvPr id="89" name="Text 87"/>
+          <p:cNvSpPr txBox="1"/>
+          <p:nvPr/>
+        </p:nvSpPr>
+        <p:spPr>
+          <a:xfrm>
+            <a:off x="6830568" y="3813048"/>
+            <a:ext cx="987552" cy="315468"/>
           </a:xfrm>
           <a:prstGeom prst="rect">
             <a:avLst/>
@@ -29872,7 +30028,7 @@
       </p:sp>
       <p:sp>
         <p:nvSpPr>
-          <p:cNvPr id="86" name="Shape 84"/>
+          <p:cNvPr id="90" name="Shape 88"/>
           <p:cNvSpPr/>
           <p:nvPr/>
         </p:nvSpPr>
@@ -29892,14 +30048,14 @@
       </p:sp>
       <p:sp>
         <p:nvSpPr>
-          <p:cNvPr id="87" name="Text 85"/>
+          <p:cNvPr id="91" name="Text 89"/>
           <p:cNvSpPr txBox="1"/>
           <p:nvPr/>
         </p:nvSpPr>
         <p:spPr>
           <a:xfrm>
             <a:off x="612648" y="4128516"/>
-            <a:ext cx="1591056" cy="315468"/>
+            <a:ext cx="1371600" cy="315468"/>
           </a:xfrm>
           <a:prstGeom prst="rect">
             <a:avLst/>
@@ -29931,14 +30087,14 @@
       </p:sp>
       <p:sp>
         <p:nvSpPr>
-          <p:cNvPr id="88" name="Text 86"/>
-          <p:cNvSpPr txBox="1"/>
-          <p:nvPr/>
-        </p:nvSpPr>
-        <p:spPr>
-          <a:xfrm>
-            <a:off x="2221992" y="4128516"/>
-            <a:ext cx="566928" cy="315468"/>
+          <p:cNvPr id="92" name="Text 90"/>
+          <p:cNvSpPr txBox="1"/>
+          <p:nvPr/>
+        </p:nvSpPr>
+        <p:spPr>
+          <a:xfrm>
+            <a:off x="2002536" y="4128516"/>
+            <a:ext cx="475488" cy="315468"/>
           </a:xfrm>
           <a:prstGeom prst="rect">
             <a:avLst/>
@@ -29970,14 +30126,14 @@
       </p:sp>
       <p:sp>
         <p:nvSpPr>
-          <p:cNvPr id="89" name="Text 87"/>
-          <p:cNvSpPr txBox="1"/>
-          <p:nvPr/>
-        </p:nvSpPr>
-        <p:spPr>
-          <a:xfrm>
-            <a:off x="2807208" y="4128516"/>
-            <a:ext cx="566928" cy="315468"/>
+          <p:cNvPr id="93" name="Text 91"/>
+          <p:cNvSpPr txBox="1"/>
+          <p:nvPr/>
+        </p:nvSpPr>
+        <p:spPr>
+          <a:xfrm>
+            <a:off x="2514600" y="4128516"/>
+            <a:ext cx="475488" cy="315468"/>
           </a:xfrm>
           <a:prstGeom prst="rect">
             <a:avLst/>
@@ -30009,14 +30165,14 @@
       </p:sp>
       <p:sp>
         <p:nvSpPr>
-          <p:cNvPr id="90" name="Shape 88"/>
-          <p:cNvSpPr/>
-          <p:nvPr/>
-        </p:nvSpPr>
-        <p:spPr>
-          <a:xfrm>
-            <a:off x="3465576" y="4240530"/>
-            <a:ext cx="731520" cy="100584"/>
+          <p:cNvPr id="94" name="Shape 92"/>
+          <p:cNvSpPr/>
+          <p:nvPr/>
+        </p:nvSpPr>
+        <p:spPr>
+          <a:xfrm>
+            <a:off x="3081528" y="4240530"/>
+            <a:ext cx="548640" cy="100584"/>
           </a:xfrm>
           <a:prstGeom prst="roundRect">
             <a:avLst>
@@ -30031,14 +30187,14 @@
       </p:sp>
       <p:sp>
         <p:nvSpPr>
-          <p:cNvPr id="91" name="Shape 89"/>
-          <p:cNvSpPr/>
-          <p:nvPr/>
-        </p:nvSpPr>
-        <p:spPr>
-          <a:xfrm>
-            <a:off x="3465576" y="4240530"/>
-            <a:ext cx="475488" cy="100584"/>
+          <p:cNvPr id="95" name="Shape 93"/>
+          <p:cNvSpPr/>
+          <p:nvPr/>
+        </p:nvSpPr>
+        <p:spPr>
+          <a:xfrm>
+            <a:off x="3081528" y="4240530"/>
+            <a:ext cx="356616" cy="100584"/>
           </a:xfrm>
           <a:prstGeom prst="roundRect">
             <a:avLst>
@@ -30053,13 +30209,13 @@
       </p:sp>
       <p:sp>
         <p:nvSpPr>
-          <p:cNvPr id="92" name="Shape 90"/>
-          <p:cNvSpPr/>
-          <p:nvPr/>
-        </p:nvSpPr>
-        <p:spPr>
-          <a:xfrm>
-            <a:off x="4165092" y="4194810"/>
+          <p:cNvPr id="96" name="Shape 94"/>
+          <p:cNvSpPr/>
+          <p:nvPr/>
+        </p:nvSpPr>
+        <p:spPr>
+          <a:xfrm>
+            <a:off x="3603650" y="4194810"/>
             <a:ext cx="20117" cy="192024"/>
           </a:xfrm>
           <a:prstGeom prst="rect">
@@ -30073,14 +30229,14 @@
       </p:sp>
       <p:sp>
         <p:nvSpPr>
-          <p:cNvPr id="93" name="Text 91"/>
-          <p:cNvSpPr txBox="1"/>
-          <p:nvPr/>
-        </p:nvSpPr>
-        <p:spPr>
-          <a:xfrm>
-            <a:off x="4233672" y="4128516"/>
-            <a:ext cx="384048" cy="315468"/>
+          <p:cNvPr id="97" name="Text 95"/>
+          <p:cNvSpPr txBox="1"/>
+          <p:nvPr/>
+        </p:nvSpPr>
+        <p:spPr>
+          <a:xfrm>
+            <a:off x="3630168" y="4128516"/>
+            <a:ext cx="329184" cy="315468"/>
           </a:xfrm>
           <a:prstGeom prst="rect">
             <a:avLst/>
@@ -30112,13 +30268,13 @@
       </p:sp>
       <p:sp>
         <p:nvSpPr>
-          <p:cNvPr id="94" name="Text 92"/>
-          <p:cNvSpPr txBox="1"/>
-          <p:nvPr/>
-        </p:nvSpPr>
-        <p:spPr>
-          <a:xfrm>
-            <a:off x="4617720" y="4128516"/>
+          <p:cNvPr id="98" name="Text 96"/>
+          <p:cNvSpPr txBox="1"/>
+          <p:nvPr/>
+        </p:nvSpPr>
+        <p:spPr>
+          <a:xfrm>
+            <a:off x="3904488" y="4128516"/>
             <a:ext cx="640080" cy="315468"/>
           </a:xfrm>
           <a:prstGeom prst="rect">
@@ -30135,6 +30291,45 @@
               <a:buNone/>
             </a:pPr>
             <a:r>
+              <a:rPr lang="en-US" sz="850" b="1" dirty="0">
+                <a:solidFill>
+                  <a:srgbClr val="3D8F5F"/>
+                </a:solidFill>
+                <a:latin typeface="Poppins" pitchFamily="34" charset="0"/>
+                <a:ea typeface="Poppins" pitchFamily="34" charset="-122"/>
+                <a:cs typeface="Poppins" pitchFamily="34" charset="-120"/>
+              </a:rPr>
+              <a:t>+899</a:t>
+            </a:r>
+            <a:endParaRPr lang="en-US" sz="850" dirty="0"/>
+          </a:p>
+        </p:txBody>
+      </p:sp>
+      <p:sp>
+        <p:nvSpPr>
+          <p:cNvPr id="99" name="Text 97"/>
+          <p:cNvSpPr txBox="1"/>
+          <p:nvPr/>
+        </p:nvSpPr>
+        <p:spPr>
+          <a:xfrm>
+            <a:off x="4599432" y="4128516"/>
+            <a:ext cx="548640" cy="315468"/>
+          </a:xfrm>
+          <a:prstGeom prst="rect">
+            <a:avLst/>
+          </a:prstGeom>
+          <a:noFill/>
+          <a:ln/>
+        </p:spPr>
+        <p:txBody>
+          <a:bodyPr wrap="square" lIns="0" tIns="0" rIns="0" bIns="0" rtlCol="0" anchor="ctr"/>
+          <a:lstStyle/>
+          <a:p>
+            <a:pPr algn="r" indent="0" marL="0">
+              <a:buNone/>
+            </a:pPr>
+            <a:r>
               <a:rPr lang="en-US" sz="850" dirty="0">
                 <a:solidFill>
                   <a:srgbClr val="5E7280"/>
@@ -30151,14 +30346,14 @@
       </p:sp>
       <p:sp>
         <p:nvSpPr>
-          <p:cNvPr id="95" name="Text 93"/>
-          <p:cNvSpPr txBox="1"/>
-          <p:nvPr/>
-        </p:nvSpPr>
-        <p:spPr>
-          <a:xfrm>
-            <a:off x="5294376" y="4128516"/>
-            <a:ext cx="658368" cy="315468"/>
+          <p:cNvPr id="100" name="Text 98"/>
+          <p:cNvSpPr txBox="1"/>
+          <p:nvPr/>
+        </p:nvSpPr>
+        <p:spPr>
+          <a:xfrm>
+            <a:off x="5184648" y="4128516"/>
+            <a:ext cx="603504" cy="315468"/>
           </a:xfrm>
           <a:prstGeom prst="rect">
             <a:avLst/>
@@ -30190,14 +30385,14 @@
       </p:sp>
       <p:sp>
         <p:nvSpPr>
-          <p:cNvPr id="96" name="Shape 94"/>
-          <p:cNvSpPr/>
-          <p:nvPr/>
-        </p:nvSpPr>
-        <p:spPr>
-          <a:xfrm>
-            <a:off x="6044184" y="4240530"/>
-            <a:ext cx="731520" cy="100584"/>
+          <p:cNvPr id="101" name="Shape 99"/>
+          <p:cNvSpPr/>
+          <p:nvPr/>
+        </p:nvSpPr>
+        <p:spPr>
+          <a:xfrm>
+            <a:off x="5879592" y="4240530"/>
+            <a:ext cx="566928" cy="100584"/>
           </a:xfrm>
           <a:prstGeom prst="roundRect">
             <a:avLst>
@@ -30212,14 +30407,14 @@
       </p:sp>
       <p:sp>
         <p:nvSpPr>
-          <p:cNvPr id="97" name="Shape 95"/>
-          <p:cNvSpPr/>
-          <p:nvPr/>
-        </p:nvSpPr>
-        <p:spPr>
-          <a:xfrm>
-            <a:off x="6044184" y="4240530"/>
-            <a:ext cx="731520" cy="100584"/>
+          <p:cNvPr id="102" name="Shape 100"/>
+          <p:cNvSpPr/>
+          <p:nvPr/>
+        </p:nvSpPr>
+        <p:spPr>
+          <a:xfrm>
+            <a:off x="5879592" y="4240530"/>
+            <a:ext cx="566928" cy="100584"/>
           </a:xfrm>
           <a:prstGeom prst="roundRect">
             <a:avLst>
@@ -30234,13 +30429,13 @@
       </p:sp>
       <p:sp>
         <p:nvSpPr>
-          <p:cNvPr id="98" name="Shape 96"/>
-          <p:cNvSpPr/>
-          <p:nvPr/>
-        </p:nvSpPr>
-        <p:spPr>
-          <a:xfrm>
-            <a:off x="6743700" y="4194810"/>
+          <p:cNvPr id="103" name="Shape 101"/>
+          <p:cNvSpPr/>
+          <p:nvPr/>
+        </p:nvSpPr>
+        <p:spPr>
+          <a:xfrm>
+            <a:off x="6419454" y="4194810"/>
             <a:ext cx="20117" cy="192024"/>
           </a:xfrm>
           <a:prstGeom prst="rect">
@@ -30254,14 +30449,14 @@
       </p:sp>
       <p:sp>
         <p:nvSpPr>
-          <p:cNvPr id="99" name="Text 97"/>
-          <p:cNvSpPr txBox="1"/>
-          <p:nvPr/>
-        </p:nvSpPr>
-        <p:spPr>
-          <a:xfrm>
-            <a:off x="6812280" y="4128516"/>
-            <a:ext cx="384048" cy="315468"/>
+          <p:cNvPr id="104" name="Text 102"/>
+          <p:cNvSpPr txBox="1"/>
+          <p:nvPr/>
+        </p:nvSpPr>
+        <p:spPr>
+          <a:xfrm>
+            <a:off x="6464808" y="4128516"/>
+            <a:ext cx="329184" cy="315468"/>
           </a:xfrm>
           <a:prstGeom prst="rect">
             <a:avLst/>
@@ -30293,14 +30488,14 @@
       </p:sp>
       <p:sp>
         <p:nvSpPr>
-          <p:cNvPr id="100" name="Text 98"/>
-          <p:cNvSpPr txBox="1"/>
-          <p:nvPr/>
-        </p:nvSpPr>
-        <p:spPr>
-          <a:xfrm>
-            <a:off x="7013448" y="4128516"/>
-            <a:ext cx="822960" cy="315468"/>
+          <p:cNvPr id="105" name="Text 103"/>
+          <p:cNvSpPr txBox="1"/>
+          <p:nvPr/>
+        </p:nvSpPr>
+        <p:spPr>
+          <a:xfrm>
+            <a:off x="6830568" y="4128516"/>
+            <a:ext cx="987552" cy="315468"/>
           </a:xfrm>
           <a:prstGeom prst="rect">
             <a:avLst/>
@@ -30332,7 +30527,7 @@
       </p:sp>
       <p:sp>
         <p:nvSpPr>
-          <p:cNvPr id="101" name="Shape 99"/>
+          <p:cNvPr id="106" name="Shape 104"/>
           <p:cNvSpPr/>
           <p:nvPr/>
         </p:nvSpPr>
@@ -30352,14 +30547,14 @@
       </p:sp>
       <p:sp>
         <p:nvSpPr>
-          <p:cNvPr id="102" name="Text 100"/>
+          <p:cNvPr id="107" name="Text 105"/>
           <p:cNvSpPr txBox="1"/>
           <p:nvPr/>
         </p:nvSpPr>
         <p:spPr>
           <a:xfrm>
             <a:off x="612648" y="4443984"/>
-            <a:ext cx="1591056" cy="315468"/>
+            <a:ext cx="1371600" cy="315468"/>
           </a:xfrm>
           <a:prstGeom prst="rect">
             <a:avLst/>
@@ -30391,14 +30586,14 @@
       </p:sp>
       <p:sp>
         <p:nvSpPr>
-          <p:cNvPr id="103" name="Text 101"/>
-          <p:cNvSpPr txBox="1"/>
-          <p:nvPr/>
-        </p:nvSpPr>
-        <p:spPr>
-          <a:xfrm>
-            <a:off x="2221992" y="4443984"/>
-            <a:ext cx="566928" cy="315468"/>
+          <p:cNvPr id="108" name="Text 106"/>
+          <p:cNvSpPr txBox="1"/>
+          <p:nvPr/>
+        </p:nvSpPr>
+        <p:spPr>
+          <a:xfrm>
+            <a:off x="2002536" y="4443984"/>
+            <a:ext cx="475488" cy="315468"/>
           </a:xfrm>
           <a:prstGeom prst="rect">
             <a:avLst/>
@@ -30430,14 +30625,14 @@
       </p:sp>
       <p:sp>
         <p:nvSpPr>
-          <p:cNvPr id="104" name="Text 102"/>
-          <p:cNvSpPr txBox="1"/>
-          <p:nvPr/>
-        </p:nvSpPr>
-        <p:spPr>
-          <a:xfrm>
-            <a:off x="2807208" y="4443984"/>
-            <a:ext cx="566928" cy="315468"/>
+          <p:cNvPr id="109" name="Text 107"/>
+          <p:cNvSpPr txBox="1"/>
+          <p:nvPr/>
+        </p:nvSpPr>
+        <p:spPr>
+          <a:xfrm>
+            <a:off x="2514600" y="4443984"/>
+            <a:ext cx="475488" cy="315468"/>
           </a:xfrm>
           <a:prstGeom prst="rect">
             <a:avLst/>
@@ -30469,14 +30664,14 @@
       </p:sp>
       <p:sp>
         <p:nvSpPr>
-          <p:cNvPr id="105" name="Shape 103"/>
-          <p:cNvSpPr/>
-          <p:nvPr/>
-        </p:nvSpPr>
-        <p:spPr>
-          <a:xfrm>
-            <a:off x="3465576" y="4555998"/>
-            <a:ext cx="731520" cy="100584"/>
+          <p:cNvPr id="110" name="Shape 108"/>
+          <p:cNvSpPr/>
+          <p:nvPr/>
+        </p:nvSpPr>
+        <p:spPr>
+          <a:xfrm>
+            <a:off x="3081528" y="4555998"/>
+            <a:ext cx="548640" cy="100584"/>
           </a:xfrm>
           <a:prstGeom prst="roundRect">
             <a:avLst>
@@ -30491,18 +30686,18 @@
       </p:sp>
       <p:sp>
         <p:nvSpPr>
-          <p:cNvPr id="106" name="Shape 104"/>
-          <p:cNvSpPr/>
-          <p:nvPr/>
-        </p:nvSpPr>
-        <p:spPr>
-          <a:xfrm>
-            <a:off x="3465576" y="4555998"/>
-            <a:ext cx="95098" cy="100584"/>
+          <p:cNvPr id="111" name="Shape 109"/>
+          <p:cNvSpPr/>
+          <p:nvPr/>
+        </p:nvSpPr>
+        <p:spPr>
+          <a:xfrm>
+            <a:off x="3081528" y="4555998"/>
+            <a:ext cx="71323" cy="100584"/>
           </a:xfrm>
           <a:prstGeom prst="roundRect">
             <a:avLst>
-              <a:gd name="adj" fmla="val 48077"/>
+              <a:gd name="adj" fmla="val 64103"/>
             </a:avLst>
           </a:prstGeom>
           <a:solidFill>
@@ -30513,13 +30708,13 @@
       </p:sp>
       <p:sp>
         <p:nvSpPr>
-          <p:cNvPr id="107" name="Shape 105"/>
-          <p:cNvSpPr/>
-          <p:nvPr/>
-        </p:nvSpPr>
-        <p:spPr>
-          <a:xfrm>
-            <a:off x="4165092" y="4510278"/>
+          <p:cNvPr id="112" name="Shape 110"/>
+          <p:cNvSpPr/>
+          <p:nvPr/>
+        </p:nvSpPr>
+        <p:spPr>
+          <a:xfrm>
+            <a:off x="3603650" y="4510278"/>
             <a:ext cx="20117" cy="192024"/>
           </a:xfrm>
           <a:prstGeom prst="rect">
@@ -30533,14 +30728,14 @@
       </p:sp>
       <p:sp>
         <p:nvSpPr>
-          <p:cNvPr id="108" name="Text 106"/>
-          <p:cNvSpPr txBox="1"/>
-          <p:nvPr/>
-        </p:nvSpPr>
-        <p:spPr>
-          <a:xfrm>
-            <a:off x="4233672" y="4443984"/>
-            <a:ext cx="384048" cy="315468"/>
+          <p:cNvPr id="113" name="Text 111"/>
+          <p:cNvSpPr txBox="1"/>
+          <p:nvPr/>
+        </p:nvSpPr>
+        <p:spPr>
+          <a:xfrm>
+            <a:off x="3630168" y="4443984"/>
+            <a:ext cx="329184" cy="315468"/>
           </a:xfrm>
           <a:prstGeom prst="rect">
             <a:avLst/>
@@ -30572,13 +30767,13 @@
       </p:sp>
       <p:sp>
         <p:nvSpPr>
-          <p:cNvPr id="109" name="Text 107"/>
-          <p:cNvSpPr txBox="1"/>
-          <p:nvPr/>
-        </p:nvSpPr>
-        <p:spPr>
-          <a:xfrm>
-            <a:off x="4617720" y="4443984"/>
+          <p:cNvPr id="114" name="Text 112"/>
+          <p:cNvSpPr txBox="1"/>
+          <p:nvPr/>
+        </p:nvSpPr>
+        <p:spPr>
+          <a:xfrm>
+            <a:off x="3904488" y="4443984"/>
             <a:ext cx="640080" cy="315468"/>
           </a:xfrm>
           <a:prstGeom prst="rect">
@@ -30595,6 +30790,45 @@
               <a:buNone/>
             </a:pPr>
             <a:r>
+              <a:rPr lang="en-US" sz="850" b="1" dirty="0">
+                <a:solidFill>
+                  <a:srgbClr val="3D8F5F"/>
+                </a:solidFill>
+                <a:latin typeface="Poppins" pitchFamily="34" charset="0"/>
+                <a:ea typeface="Poppins" pitchFamily="34" charset="-122"/>
+                <a:cs typeface="Poppins" pitchFamily="34" charset="-120"/>
+              </a:rPr>
+              <a:t>+59</a:t>
+            </a:r>
+            <a:endParaRPr lang="en-US" sz="850" dirty="0"/>
+          </a:p>
+        </p:txBody>
+      </p:sp>
+      <p:sp>
+        <p:nvSpPr>
+          <p:cNvPr id="115" name="Text 113"/>
+          <p:cNvSpPr txBox="1"/>
+          <p:nvPr/>
+        </p:nvSpPr>
+        <p:spPr>
+          <a:xfrm>
+            <a:off x="4599432" y="4443984"/>
+            <a:ext cx="548640" cy="315468"/>
+          </a:xfrm>
+          <a:prstGeom prst="rect">
+            <a:avLst/>
+          </a:prstGeom>
+          <a:noFill/>
+          <a:ln/>
+        </p:spPr>
+        <p:txBody>
+          <a:bodyPr wrap="square" lIns="0" tIns="0" rIns="0" bIns="0" rtlCol="0" anchor="ctr"/>
+          <a:lstStyle/>
+          <a:p>
+            <a:pPr algn="r" indent="0" marL="0">
+              <a:buNone/>
+            </a:pPr>
+            <a:r>
               <a:rPr lang="en-US" sz="850" dirty="0">
                 <a:solidFill>
                   <a:srgbClr val="5E7280"/>
@@ -30611,14 +30845,14 @@
       </p:sp>
       <p:sp>
         <p:nvSpPr>
-          <p:cNvPr id="110" name="Text 108"/>
-          <p:cNvSpPr txBox="1"/>
-          <p:nvPr/>
-        </p:nvSpPr>
-        <p:spPr>
-          <a:xfrm>
-            <a:off x="5294376" y="4443984"/>
-            <a:ext cx="658368" cy="315468"/>
+          <p:cNvPr id="116" name="Text 114"/>
+          <p:cNvSpPr txBox="1"/>
+          <p:nvPr/>
+        </p:nvSpPr>
+        <p:spPr>
+          <a:xfrm>
+            <a:off x="5184648" y="4443984"/>
+            <a:ext cx="603504" cy="315468"/>
           </a:xfrm>
           <a:prstGeom prst="rect">
             <a:avLst/>
@@ -30650,14 +30884,14 @@
       </p:sp>
       <p:sp>
         <p:nvSpPr>
-          <p:cNvPr id="111" name="Shape 109"/>
-          <p:cNvSpPr/>
-          <p:nvPr/>
-        </p:nvSpPr>
-        <p:spPr>
-          <a:xfrm>
-            <a:off x="6044184" y="4555998"/>
-            <a:ext cx="731520" cy="100584"/>
+          <p:cNvPr id="117" name="Shape 115"/>
+          <p:cNvSpPr/>
+          <p:nvPr/>
+        </p:nvSpPr>
+        <p:spPr>
+          <a:xfrm>
+            <a:off x="5879592" y="4555998"/>
+            <a:ext cx="566928" cy="100584"/>
           </a:xfrm>
           <a:prstGeom prst="roundRect">
             <a:avLst>
@@ -30672,14 +30906,14 @@
       </p:sp>
       <p:sp>
         <p:nvSpPr>
-          <p:cNvPr id="112" name="Shape 110"/>
-          <p:cNvSpPr/>
-          <p:nvPr/>
-        </p:nvSpPr>
-        <p:spPr>
-          <a:xfrm>
-            <a:off x="6044184" y="4555998"/>
-            <a:ext cx="190195" cy="100584"/>
+          <p:cNvPr id="118" name="Shape 116"/>
+          <p:cNvSpPr/>
+          <p:nvPr/>
+        </p:nvSpPr>
+        <p:spPr>
+          <a:xfrm>
+            <a:off x="5879592" y="4555998"/>
+            <a:ext cx="147401" cy="100584"/>
           </a:xfrm>
           <a:prstGeom prst="roundRect">
             <a:avLst>
@@ -30694,13 +30928,13 @@
       </p:sp>
       <p:sp>
         <p:nvSpPr>
-          <p:cNvPr id="113" name="Shape 111"/>
-          <p:cNvSpPr/>
-          <p:nvPr/>
-        </p:nvSpPr>
-        <p:spPr>
-          <a:xfrm>
-            <a:off x="6743700" y="4510278"/>
+          <p:cNvPr id="119" name="Shape 117"/>
+          <p:cNvSpPr/>
+          <p:nvPr/>
+        </p:nvSpPr>
+        <p:spPr>
+          <a:xfrm>
+            <a:off x="6419454" y="4510278"/>
             <a:ext cx="20117" cy="192024"/>
           </a:xfrm>
           <a:prstGeom prst="rect">
@@ -30714,14 +30948,14 @@
       </p:sp>
       <p:sp>
         <p:nvSpPr>
-          <p:cNvPr id="114" name="Text 112"/>
-          <p:cNvSpPr txBox="1"/>
-          <p:nvPr/>
-        </p:nvSpPr>
-        <p:spPr>
-          <a:xfrm>
-            <a:off x="6812280" y="4443984"/>
-            <a:ext cx="384048" cy="315468"/>
+          <p:cNvPr id="120" name="Text 118"/>
+          <p:cNvSpPr txBox="1"/>
+          <p:nvPr/>
+        </p:nvSpPr>
+        <p:spPr>
+          <a:xfrm>
+            <a:off x="6464808" y="4443984"/>
+            <a:ext cx="329184" cy="315468"/>
           </a:xfrm>
           <a:prstGeom prst="rect">
             <a:avLst/>
@@ -30753,14 +30987,14 @@
       </p:sp>
       <p:sp>
         <p:nvSpPr>
-          <p:cNvPr id="115" name="Text 113"/>
-          <p:cNvSpPr txBox="1"/>
-          <p:nvPr/>
-        </p:nvSpPr>
-        <p:spPr>
-          <a:xfrm>
-            <a:off x="7013448" y="4443984"/>
-            <a:ext cx="822960" cy="315468"/>
+          <p:cNvPr id="121" name="Text 119"/>
+          <p:cNvSpPr txBox="1"/>
+          <p:nvPr/>
+        </p:nvSpPr>
+        <p:spPr>
+          <a:xfrm>
+            <a:off x="6830568" y="4443984"/>
+            <a:ext cx="987552" cy="315468"/>
           </a:xfrm>
           <a:prstGeom prst="rect">
             <a:avLst/>
@@ -30792,7 +31026,7 @@
       </p:sp>
       <p:sp>
         <p:nvSpPr>
-          <p:cNvPr id="116" name="Shape 114"/>
+          <p:cNvPr id="122" name="Shape 120"/>
           <p:cNvSpPr/>
           <p:nvPr/>
         </p:nvSpPr>
@@ -30812,14 +31046,14 @@
       </p:sp>
       <p:sp>
         <p:nvSpPr>
-          <p:cNvPr id="117" name="Text 115"/>
+          <p:cNvPr id="123" name="Text 121"/>
           <p:cNvSpPr txBox="1"/>
           <p:nvPr/>
         </p:nvSpPr>
         <p:spPr>
           <a:xfrm>
             <a:off x="612648" y="4759452"/>
-            <a:ext cx="1591056" cy="315468"/>
+            <a:ext cx="1371600" cy="315468"/>
           </a:xfrm>
           <a:prstGeom prst="rect">
             <a:avLst/>
@@ -30851,14 +31085,14 @@
       </p:sp>
       <p:sp>
         <p:nvSpPr>
-          <p:cNvPr id="118" name="Text 116"/>
-          <p:cNvSpPr txBox="1"/>
-          <p:nvPr/>
-        </p:nvSpPr>
-        <p:spPr>
-          <a:xfrm>
-            <a:off x="2221992" y="4759452"/>
-            <a:ext cx="566928" cy="315468"/>
+          <p:cNvPr id="124" name="Text 122"/>
+          <p:cNvSpPr txBox="1"/>
+          <p:nvPr/>
+        </p:nvSpPr>
+        <p:spPr>
+          <a:xfrm>
+            <a:off x="2002536" y="4759452"/>
+            <a:ext cx="475488" cy="315468"/>
           </a:xfrm>
           <a:prstGeom prst="rect">
             <a:avLst/>
@@ -30890,14 +31124,14 @@
       </p:sp>
       <p:sp>
         <p:nvSpPr>
-          <p:cNvPr id="119" name="Text 117"/>
-          <p:cNvSpPr txBox="1"/>
-          <p:nvPr/>
-        </p:nvSpPr>
-        <p:spPr>
-          <a:xfrm>
-            <a:off x="2807208" y="4759452"/>
-            <a:ext cx="566928" cy="315468"/>
+          <p:cNvPr id="125" name="Text 123"/>
+          <p:cNvSpPr txBox="1"/>
+          <p:nvPr/>
+        </p:nvSpPr>
+        <p:spPr>
+          <a:xfrm>
+            <a:off x="2514600" y="4759452"/>
+            <a:ext cx="475488" cy="315468"/>
           </a:xfrm>
           <a:prstGeom prst="rect">
             <a:avLst/>
@@ -30929,14 +31163,14 @@
       </p:sp>
       <p:sp>
         <p:nvSpPr>
-          <p:cNvPr id="120" name="Shape 118"/>
-          <p:cNvSpPr/>
-          <p:nvPr/>
-        </p:nvSpPr>
-        <p:spPr>
-          <a:xfrm>
-            <a:off x="3465576" y="4871466"/>
-            <a:ext cx="731520" cy="100584"/>
+          <p:cNvPr id="126" name="Shape 124"/>
+          <p:cNvSpPr/>
+          <p:nvPr/>
+        </p:nvSpPr>
+        <p:spPr>
+          <a:xfrm>
+            <a:off x="3081528" y="4871466"/>
+            <a:ext cx="548640" cy="100584"/>
           </a:xfrm>
           <a:prstGeom prst="roundRect">
             <a:avLst>
@@ -30951,13 +31185,13 @@
       </p:sp>
       <p:sp>
         <p:nvSpPr>
-          <p:cNvPr id="121" name="Shape 119"/>
-          <p:cNvSpPr/>
-          <p:nvPr/>
-        </p:nvSpPr>
-        <p:spPr>
-          <a:xfrm>
-            <a:off x="3465576" y="4871466"/>
+          <p:cNvPr id="127" name="Shape 125"/>
+          <p:cNvSpPr/>
+          <p:nvPr/>
+        </p:nvSpPr>
+        <p:spPr>
+          <a:xfrm>
+            <a:off x="3081528" y="4871466"/>
             <a:ext cx="54864" cy="100584"/>
           </a:xfrm>
           <a:prstGeom prst="roundRect">
@@ -30973,13 +31207,13 @@
       </p:sp>
       <p:sp>
         <p:nvSpPr>
-          <p:cNvPr id="122" name="Shape 120"/>
-          <p:cNvSpPr/>
-          <p:nvPr/>
-        </p:nvSpPr>
-        <p:spPr>
-          <a:xfrm>
-            <a:off x="4165092" y="4825746"/>
+          <p:cNvPr id="128" name="Shape 126"/>
+          <p:cNvSpPr/>
+          <p:nvPr/>
+        </p:nvSpPr>
+        <p:spPr>
+          <a:xfrm>
+            <a:off x="3603650" y="4825746"/>
             <a:ext cx="20117" cy="192024"/>
           </a:xfrm>
           <a:prstGeom prst="rect">
@@ -30993,14 +31227,14 @@
       </p:sp>
       <p:sp>
         <p:nvSpPr>
-          <p:cNvPr id="123" name="Text 121"/>
-          <p:cNvSpPr txBox="1"/>
-          <p:nvPr/>
-        </p:nvSpPr>
-        <p:spPr>
-          <a:xfrm>
-            <a:off x="4233672" y="4759452"/>
-            <a:ext cx="384048" cy="315468"/>
+          <p:cNvPr id="129" name="Text 127"/>
+          <p:cNvSpPr txBox="1"/>
+          <p:nvPr/>
+        </p:nvSpPr>
+        <p:spPr>
+          <a:xfrm>
+            <a:off x="3630168" y="4759452"/>
+            <a:ext cx="329184" cy="315468"/>
           </a:xfrm>
           <a:prstGeom prst="rect">
             <a:avLst/>
@@ -31032,13 +31266,13 @@
       </p:sp>
       <p:sp>
         <p:nvSpPr>
-          <p:cNvPr id="124" name="Text 122"/>
-          <p:cNvSpPr txBox="1"/>
-          <p:nvPr/>
-        </p:nvSpPr>
-        <p:spPr>
-          <a:xfrm>
-            <a:off x="4617720" y="4759452"/>
+          <p:cNvPr id="130" name="Text 128"/>
+          <p:cNvSpPr txBox="1"/>
+          <p:nvPr/>
+        </p:nvSpPr>
+        <p:spPr>
+          <a:xfrm>
+            <a:off x="3904488" y="4759452"/>
             <a:ext cx="640080" cy="315468"/>
           </a:xfrm>
           <a:prstGeom prst="rect">
@@ -31057,6 +31291,45 @@
             <a:r>
               <a:rPr lang="en-US" sz="850" dirty="0">
                 <a:solidFill>
+                  <a:srgbClr val="8FA1AC"/>
+                </a:solidFill>
+                <a:latin typeface="Poppins" pitchFamily="34" charset="0"/>
+                <a:ea typeface="Poppins" pitchFamily="34" charset="-122"/>
+                <a:cs typeface="Poppins" pitchFamily="34" charset="-120"/>
+              </a:rPr>
+              <a:t>—</a:t>
+            </a:r>
+            <a:endParaRPr lang="en-US" sz="850" dirty="0"/>
+          </a:p>
+        </p:txBody>
+      </p:sp>
+      <p:sp>
+        <p:nvSpPr>
+          <p:cNvPr id="131" name="Text 129"/>
+          <p:cNvSpPr txBox="1"/>
+          <p:nvPr/>
+        </p:nvSpPr>
+        <p:spPr>
+          <a:xfrm>
+            <a:off x="4599432" y="4759452"/>
+            <a:ext cx="548640" cy="315468"/>
+          </a:xfrm>
+          <a:prstGeom prst="rect">
+            <a:avLst/>
+          </a:prstGeom>
+          <a:noFill/>
+          <a:ln/>
+        </p:spPr>
+        <p:txBody>
+          <a:bodyPr wrap="square" lIns="0" tIns="0" rIns="0" bIns="0" rtlCol="0" anchor="ctr"/>
+          <a:lstStyle/>
+          <a:p>
+            <a:pPr algn="r" indent="0" marL="0">
+              <a:buNone/>
+            </a:pPr>
+            <a:r>
+              <a:rPr lang="en-US" sz="850" dirty="0">
+                <a:solidFill>
                   <a:srgbClr val="5E7280"/>
                 </a:solidFill>
                 <a:latin typeface="Poppins" pitchFamily="34" charset="0"/>
@@ -31071,14 +31344,14 @@
       </p:sp>
       <p:sp>
         <p:nvSpPr>
-          <p:cNvPr id="125" name="Text 123"/>
-          <p:cNvSpPr txBox="1"/>
-          <p:nvPr/>
-        </p:nvSpPr>
-        <p:spPr>
-          <a:xfrm>
-            <a:off x="5294376" y="4759452"/>
-            <a:ext cx="658368" cy="315468"/>
+          <p:cNvPr id="132" name="Text 130"/>
+          <p:cNvSpPr txBox="1"/>
+          <p:nvPr/>
+        </p:nvSpPr>
+        <p:spPr>
+          <a:xfrm>
+            <a:off x="5184648" y="4759452"/>
+            <a:ext cx="603504" cy="315468"/>
           </a:xfrm>
           <a:prstGeom prst="rect">
             <a:avLst/>
@@ -31110,14 +31383,14 @@
       </p:sp>
       <p:sp>
         <p:nvSpPr>
-          <p:cNvPr id="126" name="Text 124"/>
-          <p:cNvSpPr txBox="1"/>
-          <p:nvPr/>
-        </p:nvSpPr>
-        <p:spPr>
-          <a:xfrm>
-            <a:off x="6007608" y="4759452"/>
-            <a:ext cx="969264" cy="315468"/>
+          <p:cNvPr id="133" name="Text 131"/>
+          <p:cNvSpPr txBox="1"/>
+          <p:nvPr/>
+        </p:nvSpPr>
+        <p:spPr>
+          <a:xfrm>
+            <a:off x="5843016" y="4759452"/>
+            <a:ext cx="932688" cy="315468"/>
           </a:xfrm>
           <a:prstGeom prst="rect">
             <a:avLst/>
@@ -31149,14 +31422,14 @@
       </p:sp>
       <p:sp>
         <p:nvSpPr>
-          <p:cNvPr id="127" name="Text 125"/>
-          <p:cNvSpPr txBox="1"/>
-          <p:nvPr/>
-        </p:nvSpPr>
-        <p:spPr>
-          <a:xfrm>
-            <a:off x="7013448" y="4759452"/>
-            <a:ext cx="822960" cy="315468"/>
+          <p:cNvPr id="134" name="Text 132"/>
+          <p:cNvSpPr txBox="1"/>
+          <p:nvPr/>
+        </p:nvSpPr>
+        <p:spPr>
+          <a:xfrm>
+            <a:off x="6830568" y="4759452"/>
+            <a:ext cx="987552" cy="315468"/>
           </a:xfrm>
           <a:prstGeom prst="rect">
             <a:avLst/>
@@ -31188,7 +31461,7 @@
       </p:sp>
       <p:sp>
         <p:nvSpPr>
-          <p:cNvPr id="128" name="Shape 126"/>
+          <p:cNvPr id="135" name="Shape 133"/>
           <p:cNvSpPr/>
           <p:nvPr/>
         </p:nvSpPr>
@@ -31208,14 +31481,14 @@
       </p:sp>
       <p:sp>
         <p:nvSpPr>
-          <p:cNvPr id="129" name="Text 127"/>
+          <p:cNvPr id="136" name="Text 134"/>
           <p:cNvSpPr txBox="1"/>
           <p:nvPr/>
         </p:nvSpPr>
         <p:spPr>
           <a:xfrm>
             <a:off x="612648" y="5074920"/>
-            <a:ext cx="1591056" cy="315468"/>
+            <a:ext cx="1371600" cy="315468"/>
           </a:xfrm>
           <a:prstGeom prst="rect">
             <a:avLst/>
@@ -31247,14 +31520,14 @@
       </p:sp>
       <p:sp>
         <p:nvSpPr>
-          <p:cNvPr id="130" name="Text 128"/>
-          <p:cNvSpPr txBox="1"/>
-          <p:nvPr/>
-        </p:nvSpPr>
-        <p:spPr>
-          <a:xfrm>
-            <a:off x="2221992" y="5074920"/>
-            <a:ext cx="566928" cy="315468"/>
+          <p:cNvPr id="137" name="Text 135"/>
+          <p:cNvSpPr txBox="1"/>
+          <p:nvPr/>
+        </p:nvSpPr>
+        <p:spPr>
+          <a:xfrm>
+            <a:off x="2002536" y="5074920"/>
+            <a:ext cx="475488" cy="315468"/>
           </a:xfrm>
           <a:prstGeom prst="rect">
             <a:avLst/>
@@ -31286,14 +31559,14 @@
       </p:sp>
       <p:sp>
         <p:nvSpPr>
-          <p:cNvPr id="131" name="Text 129"/>
-          <p:cNvSpPr txBox="1"/>
-          <p:nvPr/>
-        </p:nvSpPr>
-        <p:spPr>
-          <a:xfrm>
-            <a:off x="2807208" y="5074920"/>
-            <a:ext cx="566928" cy="315468"/>
+          <p:cNvPr id="138" name="Text 136"/>
+          <p:cNvSpPr txBox="1"/>
+          <p:nvPr/>
+        </p:nvSpPr>
+        <p:spPr>
+          <a:xfrm>
+            <a:off x="2514600" y="5074920"/>
+            <a:ext cx="475488" cy="315468"/>
           </a:xfrm>
           <a:prstGeom prst="rect">
             <a:avLst/>
@@ -31325,14 +31598,14 @@
       </p:sp>
       <p:sp>
         <p:nvSpPr>
-          <p:cNvPr id="132" name="Shape 130"/>
-          <p:cNvSpPr/>
-          <p:nvPr/>
-        </p:nvSpPr>
-        <p:spPr>
-          <a:xfrm>
-            <a:off x="3465576" y="5186934"/>
-            <a:ext cx="731520" cy="100584"/>
+          <p:cNvPr id="139" name="Shape 137"/>
+          <p:cNvSpPr/>
+          <p:nvPr/>
+        </p:nvSpPr>
+        <p:spPr>
+          <a:xfrm>
+            <a:off x="3081528" y="5186934"/>
+            <a:ext cx="548640" cy="100584"/>
           </a:xfrm>
           <a:prstGeom prst="roundRect">
             <a:avLst>
@@ -31347,13 +31620,13 @@
       </p:sp>
       <p:sp>
         <p:nvSpPr>
-          <p:cNvPr id="133" name="Shape 131"/>
-          <p:cNvSpPr/>
-          <p:nvPr/>
-        </p:nvSpPr>
-        <p:spPr>
-          <a:xfrm>
-            <a:off x="3465576" y="5186934"/>
+          <p:cNvPr id="140" name="Shape 138"/>
+          <p:cNvSpPr/>
+          <p:nvPr/>
+        </p:nvSpPr>
+        <p:spPr>
+          <a:xfrm>
+            <a:off x="3081528" y="5186934"/>
             <a:ext cx="54864" cy="100584"/>
           </a:xfrm>
           <a:prstGeom prst="roundRect">
@@ -31369,13 +31642,13 @@
       </p:sp>
       <p:sp>
         <p:nvSpPr>
-          <p:cNvPr id="134" name="Shape 132"/>
-          <p:cNvSpPr/>
-          <p:nvPr/>
-        </p:nvSpPr>
-        <p:spPr>
-          <a:xfrm>
-            <a:off x="4165092" y="5141214"/>
+          <p:cNvPr id="141" name="Shape 139"/>
+          <p:cNvSpPr/>
+          <p:nvPr/>
+        </p:nvSpPr>
+        <p:spPr>
+          <a:xfrm>
+            <a:off x="3603650" y="5141214"/>
             <a:ext cx="20117" cy="192024"/>
           </a:xfrm>
           <a:prstGeom prst="rect">
@@ -31389,14 +31662,14 @@
       </p:sp>
       <p:sp>
         <p:nvSpPr>
-          <p:cNvPr id="135" name="Text 133"/>
-          <p:cNvSpPr txBox="1"/>
-          <p:nvPr/>
-        </p:nvSpPr>
-        <p:spPr>
-          <a:xfrm>
-            <a:off x="4233672" y="5074920"/>
-            <a:ext cx="384048" cy="315468"/>
+          <p:cNvPr id="142" name="Text 140"/>
+          <p:cNvSpPr txBox="1"/>
+          <p:nvPr/>
+        </p:nvSpPr>
+        <p:spPr>
+          <a:xfrm>
+            <a:off x="3630168" y="5074920"/>
+            <a:ext cx="329184" cy="315468"/>
           </a:xfrm>
           <a:prstGeom prst="rect">
             <a:avLst/>
@@ -31428,13 +31701,13 @@
       </p:sp>
       <p:sp>
         <p:nvSpPr>
-          <p:cNvPr id="136" name="Text 134"/>
-          <p:cNvSpPr txBox="1"/>
-          <p:nvPr/>
-        </p:nvSpPr>
-        <p:spPr>
-          <a:xfrm>
-            <a:off x="4617720" y="5074920"/>
+          <p:cNvPr id="143" name="Text 141"/>
+          <p:cNvSpPr txBox="1"/>
+          <p:nvPr/>
+        </p:nvSpPr>
+        <p:spPr>
+          <a:xfrm>
+            <a:off x="3904488" y="5074920"/>
             <a:ext cx="640080" cy="315468"/>
           </a:xfrm>
           <a:prstGeom prst="rect">
@@ -31453,6 +31726,45 @@
             <a:r>
               <a:rPr lang="en-US" sz="850" dirty="0">
                 <a:solidFill>
+                  <a:srgbClr val="8FA1AC"/>
+                </a:solidFill>
+                <a:latin typeface="Poppins" pitchFamily="34" charset="0"/>
+                <a:ea typeface="Poppins" pitchFamily="34" charset="-122"/>
+                <a:cs typeface="Poppins" pitchFamily="34" charset="-120"/>
+              </a:rPr>
+              <a:t>—</a:t>
+            </a:r>
+            <a:endParaRPr lang="en-US" sz="850" dirty="0"/>
+          </a:p>
+        </p:txBody>
+      </p:sp>
+      <p:sp>
+        <p:nvSpPr>
+          <p:cNvPr id="144" name="Text 142"/>
+          <p:cNvSpPr txBox="1"/>
+          <p:nvPr/>
+        </p:nvSpPr>
+        <p:spPr>
+          <a:xfrm>
+            <a:off x="4599432" y="5074920"/>
+            <a:ext cx="548640" cy="315468"/>
+          </a:xfrm>
+          <a:prstGeom prst="rect">
+            <a:avLst/>
+          </a:prstGeom>
+          <a:noFill/>
+          <a:ln/>
+        </p:spPr>
+        <p:txBody>
+          <a:bodyPr wrap="square" lIns="0" tIns="0" rIns="0" bIns="0" rtlCol="0" anchor="ctr"/>
+          <a:lstStyle/>
+          <a:p>
+            <a:pPr algn="r" indent="0" marL="0">
+              <a:buNone/>
+            </a:pPr>
+            <a:r>
+              <a:rPr lang="en-US" sz="850" dirty="0">
+                <a:solidFill>
                   <a:srgbClr val="5E7280"/>
                 </a:solidFill>
                 <a:latin typeface="Poppins" pitchFamily="34" charset="0"/>
@@ -31467,14 +31779,14 @@
       </p:sp>
       <p:sp>
         <p:nvSpPr>
-          <p:cNvPr id="137" name="Text 135"/>
-          <p:cNvSpPr txBox="1"/>
-          <p:nvPr/>
-        </p:nvSpPr>
-        <p:spPr>
-          <a:xfrm>
-            <a:off x="5294376" y="5074920"/>
-            <a:ext cx="658368" cy="315468"/>
+          <p:cNvPr id="145" name="Text 143"/>
+          <p:cNvSpPr txBox="1"/>
+          <p:nvPr/>
+        </p:nvSpPr>
+        <p:spPr>
+          <a:xfrm>
+            <a:off x="5184648" y="5074920"/>
+            <a:ext cx="603504" cy="315468"/>
           </a:xfrm>
           <a:prstGeom prst="rect">
             <a:avLst/>
@@ -31506,14 +31818,14 @@
       </p:sp>
       <p:sp>
         <p:nvSpPr>
-          <p:cNvPr id="138" name="Text 136"/>
-          <p:cNvSpPr txBox="1"/>
-          <p:nvPr/>
-        </p:nvSpPr>
-        <p:spPr>
-          <a:xfrm>
-            <a:off x="6007608" y="5074920"/>
-            <a:ext cx="969264" cy="315468"/>
+          <p:cNvPr id="146" name="Text 144"/>
+          <p:cNvSpPr txBox="1"/>
+          <p:nvPr/>
+        </p:nvSpPr>
+        <p:spPr>
+          <a:xfrm>
+            <a:off x="5843016" y="5074920"/>
+            <a:ext cx="932688" cy="315468"/>
           </a:xfrm>
           <a:prstGeom prst="rect">
             <a:avLst/>
@@ -31545,14 +31857,14 @@
       </p:sp>
       <p:sp>
         <p:nvSpPr>
-          <p:cNvPr id="139" name="Text 137"/>
-          <p:cNvSpPr txBox="1"/>
-          <p:nvPr/>
-        </p:nvSpPr>
-        <p:spPr>
-          <a:xfrm>
-            <a:off x="7013448" y="5074920"/>
-            <a:ext cx="822960" cy="315468"/>
+          <p:cNvPr id="147" name="Text 145"/>
+          <p:cNvSpPr txBox="1"/>
+          <p:nvPr/>
+        </p:nvSpPr>
+        <p:spPr>
+          <a:xfrm>
+            <a:off x="6830568" y="5074920"/>
+            <a:ext cx="987552" cy="315468"/>
           </a:xfrm>
           <a:prstGeom prst="rect">
             <a:avLst/>
@@ -31584,7 +31896,7 @@
       </p:sp>
       <p:sp>
         <p:nvSpPr>
-          <p:cNvPr id="140" name="Shape 138"/>
+          <p:cNvPr id="148" name="Shape 146"/>
           <p:cNvSpPr/>
           <p:nvPr/>
         </p:nvSpPr>
@@ -31604,14 +31916,14 @@
       </p:sp>
       <p:sp>
         <p:nvSpPr>
-          <p:cNvPr id="141" name="Text 139"/>
+          <p:cNvPr id="149" name="Text 147"/>
           <p:cNvSpPr txBox="1"/>
           <p:nvPr/>
         </p:nvSpPr>
         <p:spPr>
           <a:xfrm>
             <a:off x="612648" y="5426964"/>
-            <a:ext cx="1591056" cy="274320"/>
+            <a:ext cx="1371600" cy="274320"/>
           </a:xfrm>
           <a:prstGeom prst="rect">
             <a:avLst/>
@@ -31643,14 +31955,14 @@
       </p:sp>
       <p:sp>
         <p:nvSpPr>
-          <p:cNvPr id="142" name="Text 140"/>
-          <p:cNvSpPr txBox="1"/>
-          <p:nvPr/>
-        </p:nvSpPr>
-        <p:spPr>
-          <a:xfrm>
-            <a:off x="2221992" y="5426964"/>
-            <a:ext cx="566928" cy="274320"/>
+          <p:cNvPr id="150" name="Text 148"/>
+          <p:cNvSpPr txBox="1"/>
+          <p:nvPr/>
+        </p:nvSpPr>
+        <p:spPr>
+          <a:xfrm>
+            <a:off x="2002536" y="5426964"/>
+            <a:ext cx="475488" cy="274320"/>
           </a:xfrm>
           <a:prstGeom prst="rect">
             <a:avLst/>
@@ -31682,14 +31994,14 @@
       </p:sp>
       <p:sp>
         <p:nvSpPr>
-          <p:cNvPr id="143" name="Text 141"/>
-          <p:cNvSpPr txBox="1"/>
-          <p:nvPr/>
-        </p:nvSpPr>
-        <p:spPr>
-          <a:xfrm>
-            <a:off x="2807208" y="5426964"/>
-            <a:ext cx="566928" cy="274320"/>
+          <p:cNvPr id="151" name="Text 149"/>
+          <p:cNvSpPr txBox="1"/>
+          <p:nvPr/>
+        </p:nvSpPr>
+        <p:spPr>
+          <a:xfrm>
+            <a:off x="2514600" y="5426964"/>
+            <a:ext cx="475488" cy="274320"/>
           </a:xfrm>
           <a:prstGeom prst="rect">
             <a:avLst/>
@@ -31721,13 +32033,13 @@
       </p:sp>
       <p:sp>
         <p:nvSpPr>
-          <p:cNvPr id="144" name="Text 142"/>
-          <p:cNvSpPr txBox="1"/>
-          <p:nvPr/>
-        </p:nvSpPr>
-        <p:spPr>
-          <a:xfrm>
-            <a:off x="4617720" y="5426964"/>
+          <p:cNvPr id="152" name="Text 150"/>
+          <p:cNvSpPr txBox="1"/>
+          <p:nvPr/>
+        </p:nvSpPr>
+        <p:spPr>
+          <a:xfrm>
+            <a:off x="3904488" y="5426964"/>
             <a:ext cx="640080" cy="274320"/>
           </a:xfrm>
           <a:prstGeom prst="rect">
@@ -31746,6 +32058,45 @@
             <a:r>
               <a:rPr lang="en-US" sz="850" b="1" dirty="0">
                 <a:solidFill>
+                  <a:srgbClr val="3D8F5F"/>
+                </a:solidFill>
+                <a:latin typeface="Poppins" pitchFamily="34" charset="0"/>
+                <a:ea typeface="Poppins" pitchFamily="34" charset="-122"/>
+                <a:cs typeface="Poppins" pitchFamily="34" charset="-120"/>
+              </a:rPr>
+              <a:t>+1,204</a:t>
+            </a:r>
+            <a:endParaRPr lang="en-US" sz="850" dirty="0"/>
+          </a:p>
+        </p:txBody>
+      </p:sp>
+      <p:sp>
+        <p:nvSpPr>
+          <p:cNvPr id="153" name="Text 151"/>
+          <p:cNvSpPr txBox="1"/>
+          <p:nvPr/>
+        </p:nvSpPr>
+        <p:spPr>
+          <a:xfrm>
+            <a:off x="4599432" y="5426964"/>
+            <a:ext cx="548640" cy="274320"/>
+          </a:xfrm>
+          <a:prstGeom prst="rect">
+            <a:avLst/>
+          </a:prstGeom>
+          <a:noFill/>
+          <a:ln/>
+        </p:spPr>
+        <p:txBody>
+          <a:bodyPr wrap="square" lIns="0" tIns="0" rIns="0" bIns="0" rtlCol="0" anchor="ctr"/>
+          <a:lstStyle/>
+          <a:p>
+            <a:pPr algn="r" indent="0" marL="0">
+              <a:buNone/>
+            </a:pPr>
+            <a:r>
+              <a:rPr lang="en-US" sz="850" b="1" dirty="0">
+                <a:solidFill>
                   <a:srgbClr val="12293A"/>
                 </a:solidFill>
                 <a:latin typeface="Poppins" pitchFamily="34" charset="0"/>
@@ -31760,14 +32111,14 @@
       </p:sp>
       <p:sp>
         <p:nvSpPr>
-          <p:cNvPr id="145" name="Text 143"/>
-          <p:cNvSpPr txBox="1"/>
-          <p:nvPr/>
-        </p:nvSpPr>
-        <p:spPr>
-          <a:xfrm>
-            <a:off x="5294376" y="5426964"/>
-            <a:ext cx="658368" cy="274320"/>
+          <p:cNvPr id="154" name="Text 152"/>
+          <p:cNvSpPr txBox="1"/>
+          <p:nvPr/>
+        </p:nvSpPr>
+        <p:spPr>
+          <a:xfrm>
+            <a:off x="5184648" y="5426964"/>
+            <a:ext cx="603504" cy="274320"/>
           </a:xfrm>
           <a:prstGeom prst="rect">
             <a:avLst/>
@@ -31799,14 +32150,14 @@
       </p:sp>
       <p:sp>
         <p:nvSpPr>
-          <p:cNvPr id="146" name="Text 144"/>
-          <p:cNvSpPr txBox="1"/>
-          <p:nvPr/>
-        </p:nvSpPr>
-        <p:spPr>
-          <a:xfrm>
-            <a:off x="6007608" y="5426964"/>
-            <a:ext cx="969264" cy="274320"/>
+          <p:cNvPr id="155" name="Text 153"/>
+          <p:cNvSpPr txBox="1"/>
+          <p:nvPr/>
+        </p:nvSpPr>
+        <p:spPr>
+          <a:xfrm>
+            <a:off x="5843016" y="5426964"/>
+            <a:ext cx="932688" cy="274320"/>
           </a:xfrm>
           <a:prstGeom prst="rect">
             <a:avLst/>
@@ -31838,14 +32189,14 @@
       </p:sp>
       <p:sp>
         <p:nvSpPr>
-          <p:cNvPr id="147" name="Text 145"/>
-          <p:cNvSpPr txBox="1"/>
-          <p:nvPr/>
-        </p:nvSpPr>
-        <p:spPr>
-          <a:xfrm>
-            <a:off x="7013448" y="5426964"/>
-            <a:ext cx="822960" cy="274320"/>
+          <p:cNvPr id="156" name="Text 154"/>
+          <p:cNvSpPr txBox="1"/>
+          <p:nvPr/>
+        </p:nvSpPr>
+        <p:spPr>
+          <a:xfrm>
+            <a:off x="6830568" y="5426964"/>
+            <a:ext cx="987552" cy="274320"/>
           </a:xfrm>
           <a:prstGeom prst="rect">
             <a:avLst/>
@@ -31877,7 +32228,7 @@
       </p:sp>
       <p:sp>
         <p:nvSpPr>
-          <p:cNvPr id="148" name="Text 146"/>
+          <p:cNvPr id="157" name="Text 155"/>
           <p:cNvSpPr txBox="1"/>
           <p:nvPr/>
         </p:nvSpPr>
@@ -31916,7 +32267,7 @@
       </p:sp>
       <p:sp>
         <p:nvSpPr>
-          <p:cNvPr id="149" name="Shape 147"/>
+          <p:cNvPr id="158" name="Shape 156"/>
           <p:cNvSpPr/>
           <p:nvPr/>
         </p:nvSpPr>
@@ -31945,7 +32296,7 @@
       </p:sp>
       <p:sp>
         <p:nvSpPr>
-          <p:cNvPr id="150" name="Text 148"/>
+          <p:cNvPr id="159" name="Text 157"/>
           <p:cNvSpPr txBox="1"/>
           <p:nvPr/>
         </p:nvSpPr>
@@ -31984,7 +32335,7 @@
       </p:sp>
       <p:sp>
         <p:nvSpPr>
-          <p:cNvPr id="151" name="Text 149"/>
+          <p:cNvPr id="160" name="Text 158"/>
           <p:cNvSpPr txBox="1"/>
           <p:nvPr/>
         </p:nvSpPr>
@@ -32125,7 +32476,7 @@
                 <a:ea typeface="Poppins" pitchFamily="34" charset="-122"/>
                 <a:cs typeface="Poppins" pitchFamily="34" charset="-120"/>
               </a:rPr>
-              <a:t>New MRR added $1,659 in the week. </a:t>
+              <a:t>Net new MRR moved +$1,204 in the week. </a:t>
             </a:r>
             <a:pPr indent="0" marL="0">
               <a:spcAft>
@@ -32142,7 +32493,7 @@
                 <a:ea typeface="Poppins" pitchFamily="34" charset="-122"/>
                 <a:cs typeface="Poppins" pitchFamily="34" charset="-120"/>
               </a:rPr>
-              <a:t>Q3 stands at $15,126 — 54% of the $28k OKR2 against a 97% pace mark. BRG Granville Tavern $899, Hallmark Coyote's Roadhouse $701, CSHG Walker Baker Evans $59.</a:t>
+              <a:t>Q3 stands at $15,126 — 54% of the $28k OKR2 against a 97% pace mark. New MRR added $1,659 (BRG Granville Tavern $899, Hallmark Coyote's Roadhouse $701, CSHG Walker Baker Evans $59); The Jungle Tingalpa churned $455, so net movement is +$1,204.</a:t>
             </a:r>
             <a:endParaRPr lang="en-US" sz="900" dirty="0"/>
           </a:p>
@@ -32184,7 +32535,7 @@
       </p:sp>
       <p:sp>
         <p:nvSpPr>
-          <p:cNvPr id="152" name="Shape 150"/>
+          <p:cNvPr id="161" name="Shape 159"/>
           <p:cNvSpPr/>
           <p:nvPr/>
         </p:nvSpPr>
@@ -32206,7 +32557,7 @@
       </p:sp>
       <p:sp>
         <p:nvSpPr>
-          <p:cNvPr id="153" name="Text 151"/>
+          <p:cNvPr id="162" name="Text 160"/>
           <p:cNvSpPr txBox="1"/>
           <p:nvPr/>
         </p:nvSpPr>

</xml_diff>